<commit_message>
Rebuild deck around a clear argument and add the research question
Adds a hook on the title slide and a research question slide carrying the
question and five objectives verbatim from the paper. Renames section
kickers so the spine reads as evidence, assumption, three findings,
explanations, answer. The closing slide now answers the research question
point by point instead of listing contributions.

Co-Authored-By: Claude Opus 5 <noreply@anthropic.com>
Claude-Session: https://claude.ai/code/session_01XenBzwZHz3pkr6S5KhCPqr
</commit_message>
<xml_diff>
--- a/deck/price-of-patience.pptx
+++ b/deck/price-of-patience.pptx
@@ -511,7 +511,7 @@
           <a:p>
             <a:r>
               <a:rPr lang="en-US" dirty="0"/>
-              <a:t>Open by naming the object of the talk: software left sitting inside civilian infrastructure. Say the question up front. When we find it, what does it actually tell us, and does AI change the answer. About one minute.</a:t>
+              <a:t>Open with the hook, slowly, and do not rush to the title. Right now there is foreign code inside American power and water networks. It has been there for years. Nobody has used it. We call it a warning of war. This paper asks whether it actually is one. Then move to the question. About a minute.</a:t>
             </a:r>
             <a:endParaRPr lang="en-US" dirty="0"/>
           </a:p>
@@ -599,7 +599,7 @@
           <a:p>
             <a:r>
               <a:rPr lang="en-US" dirty="0"/>
-              <a:t>Close on the four points, briefly, then the last line slowly. That sentence is what you want them to remember. Stop there and take questions.</a:t>
+              <a:t>Answer the research question directly, point by point, so the talk closes where it opened. Then the last line, slowly. That sentence is what you want them to remember. Stop and take questions.</a:t>
             </a:r>
             <a:endParaRPr lang="en-US" dirty="0"/>
           </a:p>
@@ -687,7 +687,7 @@
           <a:p>
             <a:r>
               <a:rPr lang="en-US" dirty="0"/>
-              <a:t>The striking thing is what did not happen. No theft worth the effort. Nakasone is saying, in effect, nobody puts code in a power station to read your email. Use the bottom band to make the infrastructure point: these are the systems defence itself depends on, and Guam is not a random target, it is the base you would need for a Taiwan contingency.</a:t>
+              <a:t>Read the question once from the slide, then give the plain-language version underneath. Run down the five objectives quickly, do not dwell. The audience only needs to know the shape of the study. Under a minute.</a:t>
             </a:r>
             <a:endParaRPr lang="en-US" dirty="0"/>
           </a:p>
@@ -775,7 +775,7 @@
           <a:p>
             <a:r>
               <a:rPr lang="en-US" dirty="0"/>
-              <a:t>This slide answers the obvious question: how does anyone stay inside for years without being caught. The 197 days and the three quarters figure are the two numbers worth saying out loud. They also matter later, on the AI slide, so plant them now.</a:t>
+              <a:t>The striking thing is what did not happen. No theft worth the effort. Nakasone is saying nobody puts code in a power station to read your email. Close with the Guam line: this is not a random target, it is the base you need for a Taiwan contingency.</a:t>
             </a:r>
             <a:endParaRPr lang="en-US" dirty="0"/>
           </a:p>
@@ -863,7 +863,7 @@
           <a:p>
             <a:r>
               <a:rPr lang="en-US" dirty="0"/>
-              <a:t>This is the logic the whole field runs on, put plainly. Walk the three boxes left to right. Land hard on the amber box. Tell the audience to hold on to the word expensive, because the next slides test it.</a:t>
+              <a:t>This is the logic the whole field runs on. Walk the three boxes left to right. Land hard on the amber box, and say plainly that this word, expensive, is what the study is testing.</a:t>
             </a:r>
             <a:endParaRPr lang="en-US" dirty="0"/>
           </a:p>
@@ -951,7 +951,7 @@
           <a:p>
             <a:r>
               <a:rPr lang="en-US" dirty="0"/>
-              <a:t>This is the heart of the talk. Slow right down. Read the two columns across, then deliver the bottom line. Weapons in the water supply got a memo. Stolen call records got sanctions. Let the room sit with how strange that ordering is. Give this a minute and a half.</a:t>
+              <a:t>The heart of the talk. Slow right down. Read the two columns across, then the bottom line. Weapons in the water supply got a memo. Stolen call records got sanctions. Let the room sit with how backwards that is. A minute and a half.</a:t>
             </a:r>
             <a:endParaRPr lang="en-US" dirty="0"/>
           </a:p>
@@ -1039,7 +1039,7 @@
           <a:p>
             <a:r>
               <a:rPr lang="en-US" dirty="0"/>
-              <a:t>Three short beats, one each, do not over-explain. The closing line is the point. For something to function as a warning it must be seen, believed, and land on the right desk. This fails on all three.</a:t>
+              <a:t>Three short beats, one each. The closing line is the point: seen, believed, right desk. This fails on all three.</a:t>
             </a:r>
             <a:endParaRPr lang="en-US" dirty="0"/>
           </a:p>
@@ -1127,7 +1127,7 @@
           <a:p>
             <a:r>
               <a:rPr lang="en-US" dirty="0"/>
-              <a:t>Three cases is the entire record. Two are still sitting there doing nothing. One was tried and stopped. The zero is the number to leave in the room. Pause after saying it.</a:t>
+              <a:t>Three cases is the entire record. Two are still sitting there. One was tried and stopped. The zero is the number to leave in the room. Pause after saying it.</a:t>
             </a:r>
             <a:endParaRPr lang="en-US" dirty="0"/>
           </a:p>
@@ -1215,7 +1215,7 @@
           <a:p>
             <a:r>
               <a:rPr lang="en-US" dirty="0"/>
-              <a:t>Push back on the room’s instinct that AI obviously helps attackers. The evidence points the other way for now. The bottom box is the qualifier that matters: who wins depends on who is fighting whom.</a:t>
+              <a:t>Push back on the instinct that AI obviously helps attackers. The evidence points the other way for now. The bottom box is the qualifier that matters: who wins depends on who is fighting whom.</a:t>
             </a:r>
             <a:endParaRPr lang="en-US" dirty="0"/>
           </a:p>
@@ -1303,7 +1303,7 @@
           <a:p>
             <a:r>
               <a:rPr lang="en-US" dirty="0"/>
-              <a:t>Present both fairly, then give the verdict. Years of sitting still, no punishment, effects kept carefully small: that fits B. Be honest that the paper does not decide. Saying so is a strength, not a weakness.</a:t>
+              <a:t>Present both fairly, then give the verdict. Years of sitting still, no punishment, effects kept small: that fits B. Be honest that the paper does not decide. Saying so is a strength.</a:t>
             </a:r>
             <a:endParaRPr lang="en-US" dirty="0"/>
           </a:p>
@@ -1684,7 +1684,7 @@
         </p:nvSpPr>
         <p:spPr>
           <a:xfrm>
-            <a:off x="9326880" y="-1554480"/>
+            <a:off x="9418320" y="-1645920"/>
             <a:ext cx="4937760" cy="4937760"/>
           </a:xfrm>
           <a:prstGeom prst="ellipse">
@@ -1704,7 +1704,7 @@
         </p:nvSpPr>
         <p:spPr>
           <a:xfrm>
-            <a:off x="10698480" y="4480560"/>
+            <a:off x="10789920" y="4663440"/>
             <a:ext cx="2926080" cy="2926080"/>
           </a:xfrm>
           <a:prstGeom prst="ellipse">
@@ -1724,24 +1724,24 @@
         </p:nvSpPr>
         <p:spPr>
           <a:xfrm>
-            <a:off x="640080" y="1691640"/>
-            <a:ext cx="8778240" cy="685800"/>
-          </a:xfrm>
-          <a:prstGeom prst="rect">
-            <a:avLst/>
-          </a:prstGeom>
-          <a:noFill/>
-          <a:ln/>
-        </p:spPr>
-        <p:txBody>
-          <a:bodyPr wrap="square" lIns="0" tIns="0" rIns="0" bIns="0" rtlCol="0" anchor="ctr"/>
-          <a:lstStyle/>
-          <a:p>
-            <a:pPr indent="0" marL="0">
-              <a:buNone/>
-            </a:pPr>
-            <a:r>
-              <a:rPr lang="en-US" sz="4000" b="1" dirty="0">
+            <a:off x="640080" y="658368"/>
+            <a:ext cx="10881360" cy="548640"/>
+          </a:xfrm>
+          <a:prstGeom prst="rect">
+            <a:avLst/>
+          </a:prstGeom>
+          <a:noFill/>
+          <a:ln/>
+        </p:spPr>
+        <p:txBody>
+          <a:bodyPr wrap="square" lIns="0" tIns="0" rIns="0" bIns="0" rtlCol="0" anchor="ctr"/>
+          <a:lstStyle/>
+          <a:p>
+            <a:pPr indent="0" marL="0">
+              <a:buNone/>
+            </a:pPr>
+            <a:r>
+              <a:rPr lang="en-US" sz="3200" b="1" dirty="0">
                 <a:solidFill>
                   <a:srgbClr val="FFFFFF"/>
                 </a:solidFill>
@@ -1751,7 +1751,7 @@
               </a:rPr>
               <a:t>FUTURE OF CYBER OPERATIONS</a:t>
             </a:r>
-            <a:endParaRPr lang="en-US" sz="4000" dirty="0"/>
+            <a:endParaRPr lang="en-US" sz="3200" dirty="0"/>
           </a:p>
         </p:txBody>
       </p:sp>
@@ -1763,24 +1763,24 @@
         </p:nvSpPr>
         <p:spPr>
           <a:xfrm>
-            <a:off x="640080" y="2450592"/>
-            <a:ext cx="8778240" cy="457200"/>
-          </a:xfrm>
-          <a:prstGeom prst="rect">
-            <a:avLst/>
-          </a:prstGeom>
-          <a:noFill/>
-          <a:ln/>
-        </p:spPr>
-        <p:txBody>
-          <a:bodyPr wrap="square" lIns="0" tIns="0" rIns="0" bIns="0" rtlCol="0" anchor="ctr"/>
-          <a:lstStyle/>
-          <a:p>
-            <a:pPr indent="0" marL="0">
-              <a:buNone/>
-            </a:pPr>
-            <a:r>
-              <a:rPr lang="en-US" sz="2400" dirty="0">
+            <a:off x="640080" y="1225296"/>
+            <a:ext cx="10881360" cy="384048"/>
+          </a:xfrm>
+          <a:prstGeom prst="rect">
+            <a:avLst/>
+          </a:prstGeom>
+          <a:noFill/>
+          <a:ln/>
+        </p:spPr>
+        <p:txBody>
+          <a:bodyPr wrap="square" lIns="0" tIns="0" rIns="0" bIns="0" rtlCol="0" anchor="ctr"/>
+          <a:lstStyle/>
+          <a:p>
+            <a:pPr indent="0" marL="0">
+              <a:buNone/>
+            </a:pPr>
+            <a:r>
+              <a:rPr lang="en-US" sz="2000" dirty="0">
                 <a:solidFill>
                   <a:srgbClr val="CADCFC"/>
                 </a:solidFill>
@@ -1790,7 +1790,7 @@
               </a:rPr>
               <a:t>Vulnerabilities of Critical National Infrastructure</a:t>
             </a:r>
-            <a:endParaRPr lang="en-US" sz="2400" dirty="0"/>
+            <a:endParaRPr lang="en-US" sz="2000" dirty="0"/>
           </a:p>
         </p:txBody>
       </p:sp>
@@ -1802,7 +1802,157 @@
         </p:nvSpPr>
         <p:spPr>
           <a:xfrm>
-            <a:off x="640080" y="3200400"/>
+            <a:off x="640080" y="1965960"/>
+            <a:ext cx="7315200" cy="2331720"/>
+          </a:xfrm>
+          <a:prstGeom prst="roundRect">
+            <a:avLst>
+              <a:gd name="adj" fmla="val 3137"/>
+            </a:avLst>
+          </a:prstGeom>
+          <a:solidFill>
+            <a:srgbClr val="141B45"/>
+          </a:solidFill>
+          <a:ln w="9525">
+            <a:solidFill>
+              <a:srgbClr val="E2E7F2"/>
+            </a:solidFill>
+            <a:prstDash val="solid"/>
+          </a:ln>
+        </p:spPr>
+      </p:sp>
+      <p:sp>
+        <p:nvSpPr>
+          <p:cNvPr id="7" name="Text 5"/>
+          <p:cNvSpPr/>
+          <p:nvPr/>
+        </p:nvSpPr>
+        <p:spPr>
+          <a:xfrm>
+            <a:off x="1051560" y="2176272"/>
+            <a:ext cx="6492240" cy="685800"/>
+          </a:xfrm>
+          <a:prstGeom prst="rect">
+            <a:avLst/>
+          </a:prstGeom>
+          <a:noFill/>
+          <a:ln/>
+        </p:spPr>
+        <p:txBody>
+          <a:bodyPr wrap="square" lIns="0" tIns="0" rIns="0" bIns="0" rtlCol="0" anchor="ctr"/>
+          <a:lstStyle/>
+          <a:p>
+            <a:pPr indent="0" marL="0">
+              <a:lnSpc>
+                <a:spcPts val="2700"/>
+              </a:lnSpc>
+              <a:buNone/>
+            </a:pPr>
+            <a:r>
+              <a:rPr lang="en-US" sz="2100" b="1" dirty="0">
+                <a:solidFill>
+                  <a:srgbClr val="FFFFFF"/>
+                </a:solidFill>
+                <a:latin typeface="Cambria" pitchFamily="34" charset="0"/>
+                <a:ea typeface="Cambria" pitchFamily="34" charset="-122"/>
+                <a:cs typeface="Cambria" pitchFamily="34" charset="-120"/>
+              </a:rPr>
+              <a:t>Right now, foreign code is sitting inside American power and water networks.</a:t>
+            </a:r>
+            <a:endParaRPr lang="en-US" sz="2100" dirty="0"/>
+          </a:p>
+        </p:txBody>
+      </p:sp>
+      <p:sp>
+        <p:nvSpPr>
+          <p:cNvPr id="8" name="Text 6"/>
+          <p:cNvSpPr/>
+          <p:nvPr/>
+        </p:nvSpPr>
+        <p:spPr>
+          <a:xfrm>
+            <a:off x="1051560" y="2926080"/>
+            <a:ext cx="6492240" cy="685800"/>
+          </a:xfrm>
+          <a:prstGeom prst="rect">
+            <a:avLst/>
+          </a:prstGeom>
+          <a:noFill/>
+          <a:ln/>
+        </p:spPr>
+        <p:txBody>
+          <a:bodyPr wrap="square" lIns="0" tIns="0" rIns="0" bIns="0" rtlCol="0" anchor="ctr"/>
+          <a:lstStyle/>
+          <a:p>
+            <a:pPr indent="0" marL="0">
+              <a:lnSpc>
+                <a:spcPts val="2400"/>
+              </a:lnSpc>
+              <a:buNone/>
+            </a:pPr>
+            <a:r>
+              <a:rPr lang="en-US" sz="1700" dirty="0">
+                <a:solidFill>
+                  <a:srgbClr val="CADCFC"/>
+                </a:solidFill>
+                <a:latin typeface="Calibri" pitchFamily="34" charset="0"/>
+                <a:ea typeface="Calibri" pitchFamily="34" charset="-122"/>
+                <a:cs typeface="Calibri" pitchFamily="34" charset="-120"/>
+              </a:rPr>
+              <a:t>It has been there for years. It has never been used. We call it a warning of coming war.</a:t>
+            </a:r>
+            <a:endParaRPr lang="en-US" sz="1700" dirty="0"/>
+          </a:p>
+        </p:txBody>
+      </p:sp>
+      <p:sp>
+        <p:nvSpPr>
+          <p:cNvPr id="9" name="Text 7"/>
+          <p:cNvSpPr/>
+          <p:nvPr/>
+        </p:nvSpPr>
+        <p:spPr>
+          <a:xfrm>
+            <a:off x="1051560" y="3675888"/>
+            <a:ext cx="6492240" cy="384048"/>
+          </a:xfrm>
+          <a:prstGeom prst="rect">
+            <a:avLst/>
+          </a:prstGeom>
+          <a:noFill/>
+          <a:ln/>
+        </p:spPr>
+        <p:txBody>
+          <a:bodyPr wrap="square" lIns="0" tIns="0" rIns="0" bIns="0" rtlCol="0" anchor="ctr"/>
+          <a:lstStyle/>
+          <a:p>
+            <a:pPr indent="0" marL="0">
+              <a:buNone/>
+            </a:pPr>
+            <a:r>
+              <a:rPr lang="en-US" sz="1900" b="1" dirty="0">
+                <a:solidFill>
+                  <a:srgbClr val="D98C1F"/>
+                </a:solidFill>
+                <a:latin typeface="Cambria" pitchFamily="34" charset="0"/>
+                <a:ea typeface="Cambria" pitchFamily="34" charset="-122"/>
+                <a:cs typeface="Cambria" pitchFamily="34" charset="-120"/>
+              </a:rPr>
+              <a:t>This paper asks whether it is one.</a:t>
+            </a:r>
+            <a:endParaRPr lang="en-US" sz="1900" dirty="0"/>
+          </a:p>
+        </p:txBody>
+      </p:sp>
+      <p:sp>
+        <p:nvSpPr>
+          <p:cNvPr id="10" name="Shape 8"/>
+          <p:cNvSpPr/>
+          <p:nvPr/>
+        </p:nvSpPr>
+        <p:spPr>
+          <a:xfrm>
+            <a:off x="640080" y="4617720"/>
             <a:ext cx="1005840" cy="32004"/>
           </a:xfrm>
           <a:prstGeom prst="rect">
@@ -1816,14 +1966,14 @@
       </p:sp>
       <p:sp>
         <p:nvSpPr>
-          <p:cNvPr id="7" name="Text 5"/>
-          <p:cNvSpPr/>
-          <p:nvPr/>
-        </p:nvSpPr>
-        <p:spPr>
-          <a:xfrm>
-            <a:off x="640080" y="3520440"/>
-            <a:ext cx="8778240" cy="868680"/>
+          <p:cNvPr id="11" name="Text 9"/>
+          <p:cNvSpPr/>
+          <p:nvPr/>
+        </p:nvSpPr>
+        <p:spPr>
+          <a:xfrm>
+            <a:off x="640080" y="4919472"/>
+            <a:ext cx="10058400" cy="777240"/>
           </a:xfrm>
           <a:prstGeom prst="rect">
             <a:avLst/>
@@ -1837,12 +1987,12 @@
           <a:p>
             <a:pPr indent="0" marL="0">
               <a:lnSpc>
-                <a:spcPts val="2400"/>
+                <a:spcPts val="2300"/>
               </a:lnSpc>
               <a:buNone/>
             </a:pPr>
             <a:r>
-              <a:rPr lang="en-US" sz="1600" dirty="0">
+              <a:rPr lang="en-US" sz="1500" dirty="0">
                 <a:solidFill>
                   <a:srgbClr val="C3CEEC"/>
                 </a:solidFill>
@@ -1850,19 +2000,19 @@
                 <a:ea typeface="Calibri" pitchFamily="34" charset="-122"/>
                 <a:cs typeface="Calibri" pitchFamily="34" charset="-120"/>
               </a:rPr>
-              <a:t>The Price of Patience: what foreign code inside our infrastructure</a:t>
-            </a:r>
-            <a:endParaRPr lang="en-US" sz="1600" dirty="0"/>
+              <a:t>The Price of Patience: what foreign code inside our infrastructure really tells us,</a:t>
+            </a:r>
+            <a:endParaRPr lang="en-US" sz="1500" dirty="0"/>
           </a:p>
           <a:p>
             <a:pPr indent="0" marL="0">
               <a:lnSpc>
-                <a:spcPts val="2400"/>
+                <a:spcPts val="2300"/>
               </a:lnSpc>
               <a:buNone/>
             </a:pPr>
             <a:r>
-              <a:rPr lang="en-US" sz="1600" dirty="0">
+              <a:rPr lang="en-US" sz="1500" dirty="0">
                 <a:solidFill>
                   <a:srgbClr val="C3CEEC"/>
                 </a:solidFill>
@@ -1870,38 +2020,38 @@
                 <a:ea typeface="Calibri" pitchFamily="34" charset="-122"/>
                 <a:cs typeface="Calibri" pitchFamily="34" charset="-120"/>
               </a:rPr>
-              <a:t>really tells us, and what artificial intelligence does to that message</a:t>
-            </a:r>
-            <a:endParaRPr lang="en-US" sz="1600" dirty="0"/>
-          </a:p>
-        </p:txBody>
-      </p:sp>
-      <p:sp>
-        <p:nvSpPr>
-          <p:cNvPr id="8" name="Text 6"/>
-          <p:cNvSpPr/>
-          <p:nvPr/>
-        </p:nvSpPr>
-        <p:spPr>
-          <a:xfrm>
-            <a:off x="640080" y="4617720"/>
-            <a:ext cx="8778240" cy="274320"/>
-          </a:xfrm>
-          <a:prstGeom prst="rect">
-            <a:avLst/>
-          </a:prstGeom>
-          <a:noFill/>
-          <a:ln/>
-        </p:spPr>
-        <p:txBody>
-          <a:bodyPr wrap="square" lIns="0" tIns="0" rIns="0" bIns="0" rtlCol="0" anchor="ctr"/>
-          <a:lstStyle/>
-          <a:p>
-            <a:pPr indent="0" marL="0">
-              <a:buNone/>
-            </a:pPr>
-            <a:r>
-              <a:rPr lang="en-US" sz="1350" dirty="0">
+              <a:t>and what artificial intelligence does to that message</a:t>
+            </a:r>
+            <a:endParaRPr lang="en-US" sz="1500" dirty="0"/>
+          </a:p>
+        </p:txBody>
+      </p:sp>
+      <p:sp>
+        <p:nvSpPr>
+          <p:cNvPr id="12" name="Text 10"/>
+          <p:cNvSpPr/>
+          <p:nvPr/>
+        </p:nvSpPr>
+        <p:spPr>
+          <a:xfrm>
+            <a:off x="640080" y="5852160"/>
+            <a:ext cx="10058400" cy="274320"/>
+          </a:xfrm>
+          <a:prstGeom prst="rect">
+            <a:avLst/>
+          </a:prstGeom>
+          <a:noFill/>
+          <a:ln/>
+        </p:spPr>
+        <p:txBody>
+          <a:bodyPr wrap="square" lIns="0" tIns="0" rIns="0" bIns="0" rtlCol="0" anchor="ctr"/>
+          <a:lstStyle/>
+          <a:p>
+            <a:pPr indent="0" marL="0">
+              <a:buNone/>
+            </a:pPr>
+            <a:r>
+              <a:rPr lang="en-US" sz="1300" dirty="0">
                 <a:solidFill>
                   <a:srgbClr val="A9B6DC"/>
                 </a:solidFill>
@@ -1911,7 +2061,7 @@
               </a:rPr>
               <a:t>Based on sixteen studies of cyber conflict, 2018 to 2026</a:t>
             </a:r>
-            <a:endParaRPr lang="en-US" sz="1350" dirty="0"/>
+            <a:endParaRPr lang="en-US" sz="1300" dirty="0"/>
           </a:p>
         </p:txBody>
       </p:sp>
@@ -1955,7 +2105,7 @@
         </p:nvSpPr>
         <p:spPr>
           <a:xfrm>
-            <a:off x="-1737360" y="3931920"/>
+            <a:off x="-1737360" y="4023360"/>
             <a:ext cx="4572000" cy="4572000"/>
           </a:xfrm>
           <a:prstGeom prst="ellipse">
@@ -1975,7 +2125,7 @@
         </p:nvSpPr>
         <p:spPr>
           <a:xfrm>
-            <a:off x="10972800" y="-1188720"/>
+            <a:off x="11064240" y="-1280160"/>
             <a:ext cx="3291840" cy="3291840"/>
           </a:xfrm>
           <a:prstGeom prst="ellipse">
@@ -1995,24 +2145,24 @@
         </p:nvSpPr>
         <p:spPr>
           <a:xfrm>
-            <a:off x="640080" y="566928"/>
-            <a:ext cx="10881360" cy="548640"/>
-          </a:xfrm>
-          <a:prstGeom prst="rect">
-            <a:avLst/>
-          </a:prstGeom>
-          <a:noFill/>
-          <a:ln/>
-        </p:spPr>
-        <p:txBody>
-          <a:bodyPr wrap="square" lIns="0" tIns="0" rIns="0" bIns="0" rtlCol="0" anchor="ctr"/>
-          <a:lstStyle/>
-          <a:p>
-            <a:pPr indent="0" marL="0">
-              <a:buNone/>
-            </a:pPr>
-            <a:r>
-              <a:rPr lang="en-US" sz="3200" b="1" dirty="0">
+            <a:off x="640080" y="548640"/>
+            <a:ext cx="10881360" cy="502920"/>
+          </a:xfrm>
+          <a:prstGeom prst="rect">
+            <a:avLst/>
+          </a:prstGeom>
+          <a:noFill/>
+          <a:ln/>
+        </p:spPr>
+        <p:txBody>
+          <a:bodyPr wrap="square" lIns="0" tIns="0" rIns="0" bIns="0" rtlCol="0" anchor="ctr"/>
+          <a:lstStyle/>
+          <a:p>
+            <a:pPr indent="0" marL="0">
+              <a:buNone/>
+            </a:pPr>
+            <a:r>
+              <a:rPr lang="en-US" sz="3000" b="1" dirty="0">
                 <a:solidFill>
                   <a:srgbClr val="FFFFFF"/>
                 </a:solidFill>
@@ -2020,9 +2170,9 @@
                 <a:ea typeface="Cambria" pitchFamily="34" charset="-122"/>
                 <a:cs typeface="Cambria" pitchFamily="34" charset="-120"/>
               </a:rPr>
-              <a:t>What this means</a:t>
-            </a:r>
-            <a:endParaRPr lang="en-US" sz="3200" dirty="0"/>
+              <a:t>Answering the question</a:t>
+            </a:r>
+            <a:endParaRPr lang="en-US" sz="3000" dirty="0"/>
           </a:p>
         </p:txBody>
       </p:sp>
@@ -2034,7 +2184,7 @@
         </p:nvSpPr>
         <p:spPr>
           <a:xfrm>
-            <a:off x="640080" y="1325880"/>
+            <a:off x="640080" y="1280160"/>
             <a:ext cx="502920" cy="502920"/>
           </a:xfrm>
           <a:prstGeom prst="ellipse">
@@ -2054,7 +2204,7 @@
         </p:nvSpPr>
         <p:spPr>
           <a:xfrm>
-            <a:off x="640080" y="1325880"/>
+            <a:off x="640080" y="1280160"/>
             <a:ext cx="502920" cy="502920"/>
           </a:xfrm>
           <a:prstGeom prst="rect">
@@ -2093,8 +2243,8 @@
         </p:nvSpPr>
         <p:spPr>
           <a:xfrm>
-            <a:off x="1417320" y="1307592"/>
-            <a:ext cx="2286000" cy="320040"/>
+            <a:off x="1417320" y="1261872"/>
+            <a:ext cx="2834640" cy="320040"/>
           </a:xfrm>
           <a:prstGeom prst="rect">
             <a:avLst/>
@@ -2118,7 +2268,7 @@
                 <a:ea typeface="Cambria" pitchFamily="34" charset="-122"/>
                 <a:cs typeface="Cambria" pitchFamily="34" charset="-120"/>
               </a:rPr>
-              <a:t>For scholarship</a:t>
+              <a:t>Is it a signal?</a:t>
             </a:r>
             <a:endParaRPr lang="en-US" sz="1550" dirty="0"/>
           </a:p>
@@ -2132,8 +2282,8 @@
         </p:nvSpPr>
         <p:spPr>
           <a:xfrm>
-            <a:off x="3840480" y="1307592"/>
-            <a:ext cx="7680960" cy="822960"/>
+            <a:off x="4389120" y="1261872"/>
+            <a:ext cx="7132320" cy="868680"/>
           </a:xfrm>
           <a:prstGeom prst="rect">
             <a:avLst/>
@@ -2160,7 +2310,7 @@
                 <a:ea typeface="Calibri" pitchFamily="34" charset="-122"/>
                 <a:cs typeface="Calibri" pitchFamily="34" charset="-120"/>
               </a:rPr>
-              <a:t>It joins two findings nobody had put together: what analysts say this activity means, and how governments actually respond to it.</a:t>
+              <a:t>On the evidence, it does not function as one. It is not noticed, it is denied by its sender, and it draws a technical answer rather than a political one.</a:t>
             </a:r>
             <a:endParaRPr lang="en-US" sz="1350" dirty="0"/>
           </a:p>
@@ -2174,7 +2324,7 @@
         </p:nvSpPr>
         <p:spPr>
           <a:xfrm>
-            <a:off x="640080" y="2313432"/>
+            <a:off x="640080" y="2304288"/>
             <a:ext cx="502920" cy="502920"/>
           </a:xfrm>
           <a:prstGeom prst="ellipse">
@@ -2194,7 +2344,7 @@
         </p:nvSpPr>
         <p:spPr>
           <a:xfrm>
-            <a:off x="640080" y="2313432"/>
+            <a:off x="640080" y="2304288"/>
             <a:ext cx="502920" cy="502920"/>
           </a:xfrm>
           <a:prstGeom prst="rect">
@@ -2233,8 +2383,8 @@
         </p:nvSpPr>
         <p:spPr>
           <a:xfrm>
-            <a:off x="1417320" y="2295144"/>
-            <a:ext cx="2286000" cy="320040"/>
+            <a:off x="1417320" y="2286000"/>
+            <a:ext cx="2834640" cy="320040"/>
           </a:xfrm>
           <a:prstGeom prst="rect">
             <a:avLst/>
@@ -2258,7 +2408,7 @@
                 <a:ea typeface="Cambria" pitchFamily="34" charset="-122"/>
                 <a:cs typeface="Cambria" pitchFamily="34" charset="-120"/>
               </a:rPr>
-              <a:t>For the argument</a:t>
+              <a:t>Does AI shift the balance?</a:t>
             </a:r>
             <a:endParaRPr lang="en-US" sz="1550" dirty="0"/>
           </a:p>
@@ -2272,8 +2422,8 @@
         </p:nvSpPr>
         <p:spPr>
           <a:xfrm>
-            <a:off x="3840480" y="2295144"/>
-            <a:ext cx="7680960" cy="822960"/>
+            <a:off x="4389120" y="2286000"/>
+            <a:ext cx="7132320" cy="868680"/>
           </a:xfrm>
           <a:prstGeom prst="rect">
             <a:avLst/>
@@ -2300,7 +2450,7 @@
                 <a:ea typeface="Calibri" pitchFamily="34" charset="-122"/>
                 <a:cs typeface="Calibri" pitchFamily="34" charset="-120"/>
               </a:rPr>
-              <a:t>It questions the assumption underneath the standard reading, that staying hidden is expensive, and asks what AI does to it.</a:t>
+              <a:t>Not yet in the attacker’s favour. Automatic attack tools are still theoretical, and the AI being built is mostly defensive.</a:t>
             </a:r>
             <a:endParaRPr lang="en-US" sz="1350" dirty="0"/>
           </a:p>
@@ -2314,7 +2464,7 @@
         </p:nvSpPr>
         <p:spPr>
           <a:xfrm>
-            <a:off x="640080" y="3300984"/>
+            <a:off x="640080" y="3328416"/>
             <a:ext cx="502920" cy="502920"/>
           </a:xfrm>
           <a:prstGeom prst="ellipse">
@@ -2334,7 +2484,7 @@
         </p:nvSpPr>
         <p:spPr>
           <a:xfrm>
-            <a:off x="640080" y="3300984"/>
+            <a:off x="640080" y="3328416"/>
             <a:ext cx="502920" cy="502920"/>
           </a:xfrm>
           <a:prstGeom prst="rect">
@@ -2373,8 +2523,8 @@
         </p:nvSpPr>
         <p:spPr>
           <a:xfrm>
-            <a:off x="1417320" y="3282696"/>
-            <a:ext cx="2286000" cy="320040"/>
+            <a:off x="1417320" y="3310128"/>
+            <a:ext cx="2834640" cy="320040"/>
           </a:xfrm>
           <a:prstGeom prst="rect">
             <a:avLst/>
@@ -2398,7 +2548,7 @@
                 <a:ea typeface="Cambria" pitchFamily="34" charset="-122"/>
                 <a:cs typeface="Cambria" pitchFamily="34" charset="-120"/>
               </a:rPr>
-              <a:t>For the record</a:t>
+              <a:t>When is it destabilising?</a:t>
             </a:r>
             <a:endParaRPr lang="en-US" sz="1550" dirty="0"/>
           </a:p>
@@ -2412,8 +2562,8 @@
         </p:nvSpPr>
         <p:spPr>
           <a:xfrm>
-            <a:off x="3840480" y="3282696"/>
-            <a:ext cx="7680960" cy="822960"/>
+            <a:off x="4389120" y="3310128"/>
+            <a:ext cx="7132320" cy="868680"/>
           </a:xfrm>
           <a:prstGeom prst="rect">
             <a:avLst/>
@@ -2440,7 +2590,7 @@
                 <a:ea typeface="Calibri" pitchFamily="34" charset="-122"/>
                 <a:cs typeface="Calibri" pitchFamily="34" charset="-120"/>
               </a:rPr>
-              <a:t>It states a fact the field has not faced. There is no case where this led to a successful attack.</a:t>
+              <a:t>Not when it is used, but when it is misread. Over-read it and we escalate over nothing. Under-read it and we file real preparation as a maintenance job.</a:t>
             </a:r>
             <a:endParaRPr lang="en-US" sz="1350" dirty="0"/>
           </a:p>
@@ -2454,7 +2604,7 @@
         </p:nvSpPr>
         <p:spPr>
           <a:xfrm>
-            <a:off x="640080" y="4288536"/>
+            <a:off x="640080" y="4352544"/>
             <a:ext cx="502920" cy="502920"/>
           </a:xfrm>
           <a:prstGeom prst="ellipse">
@@ -2474,7 +2624,7 @@
         </p:nvSpPr>
         <p:spPr>
           <a:xfrm>
-            <a:off x="640080" y="4288536"/>
+            <a:off x="640080" y="4352544"/>
             <a:ext cx="502920" cy="502920"/>
           </a:xfrm>
           <a:prstGeom prst="rect">
@@ -2513,8 +2663,8 @@
         </p:nvSpPr>
         <p:spPr>
           <a:xfrm>
-            <a:off x="1417320" y="4270248"/>
-            <a:ext cx="2286000" cy="320040"/>
+            <a:off x="1417320" y="4334256"/>
+            <a:ext cx="2834640" cy="320040"/>
           </a:xfrm>
           <a:prstGeom prst="rect">
             <a:avLst/>
@@ -2538,7 +2688,7 @@
                 <a:ea typeface="Cambria" pitchFamily="34" charset="-122"/>
                 <a:cs typeface="Cambria" pitchFamily="34" charset="-120"/>
               </a:rPr>
-              <a:t>For policy</a:t>
+              <a:t>What is left to do?</a:t>
             </a:r>
             <a:endParaRPr lang="en-US" sz="1550" dirty="0"/>
           </a:p>
@@ -2552,8 +2702,8 @@
         </p:nvSpPr>
         <p:spPr>
           <a:xfrm>
-            <a:off x="3840480" y="4270248"/>
-            <a:ext cx="7680960" cy="822960"/>
+            <a:off x="4389120" y="4334256"/>
+            <a:ext cx="7132320" cy="868680"/>
           </a:xfrm>
           <a:prstGeom prst="rect">
             <a:avLst/>
@@ -2580,7 +2730,7 @@
                 <a:ea typeface="Calibri" pitchFamily="34" charset="-122"/>
                 <a:cs typeface="Calibri" pitchFamily="34" charset="-120"/>
               </a:rPr>
-              <a:t>Over-read it and we may escalate over nothing. Under-read it and we may file real preparation as a maintenance job. Both errors come from the same weak signal.</a:t>
+              <a:t>Test which of the two explanations holds, by tracking whether the gap between interpretation and response widens as automation spreads.</a:t>
             </a:r>
             <a:endParaRPr lang="en-US" sz="1350" dirty="0"/>
           </a:p>
@@ -2594,7 +2744,7 @@
         </p:nvSpPr>
         <p:spPr>
           <a:xfrm>
-            <a:off x="640080" y="5468112"/>
+            <a:off x="640080" y="5532120"/>
             <a:ext cx="1005840" cy="32004"/>
           </a:xfrm>
           <a:prstGeom prst="rect">
@@ -2614,7 +2764,7 @@
         </p:nvSpPr>
         <p:spPr>
           <a:xfrm>
-            <a:off x="640080" y="5715000"/>
+            <a:off x="640080" y="5779008"/>
             <a:ext cx="10881360" cy="457200"/>
           </a:xfrm>
           <a:prstGeom prst="rect">
@@ -2653,7 +2803,7 @@
         </p:nvSpPr>
         <p:spPr>
           <a:xfrm>
-            <a:off x="640080" y="6263640"/>
+            <a:off x="640080" y="6327648"/>
             <a:ext cx="10881360" cy="320040"/>
           </a:xfrm>
           <a:prstGeom prst="rect">
@@ -2749,7 +2899,7 @@
                 <a:ea typeface="Calibri" pitchFamily="34" charset="-122"/>
                 <a:cs typeface="Calibri" pitchFamily="34" charset="-120"/>
               </a:rPr>
-              <a:t>THE PUZZLE</a:t>
+              <a:t>RESEARCH QUESTION</a:t>
             </a:r>
             <a:endParaRPr lang="en-US" sz="1200" dirty="0"/>
           </a:p>
@@ -2788,7 +2938,7 @@
                 <a:ea typeface="Cambria" pitchFamily="34" charset="-122"/>
                 <a:cs typeface="Cambria" pitchFamily="34" charset="-120"/>
               </a:rPr>
-              <a:t>An intrusion that made no sense as spying</a:t>
+              <a:t>What this study asks</a:t>
             </a:r>
             <a:endParaRPr lang="en-US" sz="3000" dirty="0"/>
           </a:p>
@@ -2796,192 +2946,18 @@
       </p:sp>
       <p:sp>
         <p:nvSpPr>
-          <p:cNvPr id="4" name="Text 2"/>
-          <p:cNvSpPr/>
-          <p:nvPr/>
-        </p:nvSpPr>
-        <p:spPr>
-          <a:xfrm>
-            <a:off x="640080" y="1298448"/>
-            <a:ext cx="6035040" cy="1234440"/>
-          </a:xfrm>
-          <a:prstGeom prst="rect">
-            <a:avLst/>
-          </a:prstGeom>
-          <a:noFill/>
-          <a:ln/>
-        </p:spPr>
-        <p:txBody>
-          <a:bodyPr wrap="square" lIns="0" tIns="0" rIns="0" bIns="0" rtlCol="0" anchor="ctr"/>
-          <a:lstStyle/>
-          <a:p>
-            <a:pPr indent="0" marL="0">
-              <a:lnSpc>
-                <a:spcPts val="2200"/>
-              </a:lnSpc>
-              <a:buNone/>
-            </a:pPr>
-            <a:r>
-              <a:rPr lang="en-US" sz="1550" b="1" dirty="0">
-                <a:solidFill>
-                  <a:srgbClr val="22252E"/>
-                </a:solidFill>
-                <a:latin typeface="Calibri" pitchFamily="34" charset="0"/>
-                <a:ea typeface="Calibri" pitchFamily="34" charset="-122"/>
-                <a:cs typeface="Calibri" pitchFamily="34" charset="-120"/>
-              </a:rPr>
-              <a:t>May 2023.</a:t>
-            </a:r>
-            <a:pPr indent="0" marL="0">
-              <a:lnSpc>
-                <a:spcPts val="2200"/>
-              </a:lnSpc>
-              <a:buNone/>
-            </a:pPr>
-            <a:r>
-              <a:rPr lang="en-US" sz="1550" dirty="0">
-                <a:solidFill>
-                  <a:srgbClr val="22252E"/>
-                </a:solidFill>
-                <a:latin typeface="Calibri" pitchFamily="34" charset="0"/>
-                <a:ea typeface="Calibri" pitchFamily="34" charset="-122"/>
-                <a:cs typeface="Calibri" pitchFamily="34" charset="-120"/>
-              </a:rPr>
-              <a:t> The United States and its Five Eyes partners named China as the source of a campaign called </a:t>
-            </a:r>
-            <a:pPr indent="0" marL="0">
-              <a:lnSpc>
-                <a:spcPts val="2200"/>
-              </a:lnSpc>
-              <a:buNone/>
-            </a:pPr>
-            <a:r>
-              <a:rPr lang="en-US" sz="1550" b="1" dirty="0">
-                <a:solidFill>
-                  <a:srgbClr val="22252E"/>
-                </a:solidFill>
-                <a:latin typeface="Calibri" pitchFamily="34" charset="0"/>
-                <a:ea typeface="Calibri" pitchFamily="34" charset="-122"/>
-                <a:cs typeface="Calibri" pitchFamily="34" charset="-120"/>
-              </a:rPr>
-              <a:t>Volt Typhoon</a:t>
-            </a:r>
-            <a:pPr indent="0" marL="0">
-              <a:lnSpc>
-                <a:spcPts val="2200"/>
-              </a:lnSpc>
-              <a:buNone/>
-            </a:pPr>
-            <a:r>
-              <a:rPr lang="en-US" sz="1550" dirty="0">
-                <a:solidFill>
-                  <a:srgbClr val="22252E"/>
-                </a:solidFill>
-                <a:latin typeface="Calibri" pitchFamily="34" charset="0"/>
-                <a:ea typeface="Calibri" pitchFamily="34" charset="-122"/>
-                <a:cs typeface="Calibri" pitchFamily="34" charset="-120"/>
-              </a:rPr>
-              <a:t>. Operators had been living inside American energy, water, communications and transport networks for an extended period.</a:t>
-            </a:r>
-            <a:endParaRPr lang="en-US" sz="1550" dirty="0"/>
-          </a:p>
-        </p:txBody>
-      </p:sp>
-      <p:sp>
-        <p:nvSpPr>
-          <p:cNvPr id="5" name="Text 3"/>
-          <p:cNvSpPr/>
-          <p:nvPr/>
-        </p:nvSpPr>
-        <p:spPr>
-          <a:xfrm>
-            <a:off x="640080" y="2670048"/>
-            <a:ext cx="6035040" cy="365760"/>
-          </a:xfrm>
-          <a:prstGeom prst="rect">
-            <a:avLst/>
-          </a:prstGeom>
-          <a:noFill/>
-          <a:ln/>
-        </p:spPr>
-        <p:txBody>
-          <a:bodyPr wrap="square" lIns="0" tIns="0" rIns="0" bIns="0" rtlCol="0" anchor="ctr"/>
-          <a:lstStyle/>
-          <a:p>
-            <a:pPr indent="0" marL="0">
-              <a:buNone/>
-            </a:pPr>
-            <a:r>
-              <a:rPr lang="en-US" sz="2200" b="1" dirty="0">
-                <a:solidFill>
-                  <a:srgbClr val="1E2761"/>
-                </a:solidFill>
-                <a:latin typeface="Cambria" pitchFamily="34" charset="0"/>
-                <a:ea typeface="Cambria" pitchFamily="34" charset="-122"/>
-                <a:cs typeface="Cambria" pitchFamily="34" charset="-120"/>
-              </a:rPr>
-              <a:t>They took almost nothing.</a:t>
-            </a:r>
-            <a:endParaRPr lang="en-US" sz="2200" dirty="0"/>
-          </a:p>
-        </p:txBody>
-      </p:sp>
-      <p:sp>
-        <p:nvSpPr>
-          <p:cNvPr id="6" name="Text 4"/>
-          <p:cNvSpPr/>
-          <p:nvPr/>
-        </p:nvSpPr>
-        <p:spPr>
-          <a:xfrm>
-            <a:off x="640080" y="3072384"/>
-            <a:ext cx="6035040" cy="640080"/>
-          </a:xfrm>
-          <a:prstGeom prst="rect">
-            <a:avLst/>
-          </a:prstGeom>
-          <a:noFill/>
-          <a:ln/>
-        </p:spPr>
-        <p:txBody>
-          <a:bodyPr wrap="square" lIns="0" tIns="0" rIns="0" bIns="0" rtlCol="0" anchor="ctr"/>
-          <a:lstStyle/>
-          <a:p>
-            <a:pPr indent="0" marL="0">
-              <a:lnSpc>
-                <a:spcPts val="2000"/>
-              </a:lnSpc>
-              <a:buNone/>
-            </a:pPr>
-            <a:r>
-              <a:rPr lang="en-US" sz="1450" dirty="0">
-                <a:solidFill>
-                  <a:srgbClr val="6A6F7D"/>
-                </a:solidFill>
-                <a:latin typeface="Calibri" pitchFamily="34" charset="0"/>
-                <a:ea typeface="Calibri" pitchFamily="34" charset="-122"/>
-                <a:cs typeface="Calibri" pitchFamily="34" charset="-120"/>
-              </a:rPr>
-              <a:t>That is the puzzle. A spy steals and leaves. These operators arrived, settled in, and waited.</a:t>
-            </a:r>
-            <a:endParaRPr lang="en-US" sz="1450" dirty="0"/>
-          </a:p>
-        </p:txBody>
-      </p:sp>
-      <p:sp>
-        <p:nvSpPr>
-          <p:cNvPr id="7" name="Shape 5"/>
-          <p:cNvSpPr/>
-          <p:nvPr/>
-        </p:nvSpPr>
-        <p:spPr>
-          <a:xfrm>
-            <a:off x="640080" y="3858768"/>
-            <a:ext cx="6035040" cy="1371600"/>
+          <p:cNvPr id="4" name="Shape 2"/>
+          <p:cNvSpPr/>
+          <p:nvPr/>
+        </p:nvSpPr>
+        <p:spPr>
+          <a:xfrm>
+            <a:off x="640080" y="1234440"/>
+            <a:ext cx="10881360" cy="1463040"/>
           </a:xfrm>
           <a:prstGeom prst="roundRect">
             <a:avLst>
-              <a:gd name="adj" fmla="val 5333"/>
+              <a:gd name="adj" fmla="val 5000"/>
             </a:avLst>
           </a:prstGeom>
           <a:solidFill>
@@ -2997,14 +2973,14 @@
       </p:sp>
       <p:sp>
         <p:nvSpPr>
-          <p:cNvPr id="8" name="Text 6"/>
-          <p:cNvSpPr/>
-          <p:nvPr/>
-        </p:nvSpPr>
-        <p:spPr>
-          <a:xfrm>
-            <a:off x="960120" y="4041648"/>
-            <a:ext cx="5440680" cy="1005840"/>
+          <p:cNvPr id="5" name="Text 3"/>
+          <p:cNvSpPr/>
+          <p:nvPr/>
+        </p:nvSpPr>
+        <p:spPr>
+          <a:xfrm>
+            <a:off x="1051560" y="1389888"/>
+            <a:ext cx="10058400" cy="1188720"/>
           </a:xfrm>
           <a:prstGeom prst="rect">
             <a:avLst/>
@@ -3018,12 +2994,54 @@
           <a:p>
             <a:pPr indent="0" marL="0">
               <a:lnSpc>
-                <a:spcPts val="2000"/>
+                <a:spcPts val="2600"/>
               </a:lnSpc>
               <a:buNone/>
             </a:pPr>
             <a:r>
-              <a:rPr lang="en-US" sz="1400" i="1" dirty="0">
+              <a:rPr lang="en-US" sz="1850" i="1" dirty="0">
+                <a:solidFill>
+                  <a:srgbClr val="1E2761"/>
+                </a:solidFill>
+                <a:latin typeface="Cambria" pitchFamily="34" charset="0"/>
+                <a:ea typeface="Cambria" pitchFamily="34" charset="-122"/>
+                <a:cs typeface="Cambria" pitchFamily="34" charset="-120"/>
+              </a:rPr>
+              <a:t>How fast and how far will AI and machine autonomy shift the balance between attack and defence, and when does pre-positioning count as a strategic signal or as a cause of instability?</a:t>
+            </a:r>
+            <a:endParaRPr lang="en-US" sz="1850" dirty="0"/>
+          </a:p>
+        </p:txBody>
+      </p:sp>
+      <p:sp>
+        <p:nvSpPr>
+          <p:cNvPr id="6" name="Text 4"/>
+          <p:cNvSpPr/>
+          <p:nvPr/>
+        </p:nvSpPr>
+        <p:spPr>
+          <a:xfrm>
+            <a:off x="640080" y="2852928"/>
+            <a:ext cx="10881360" cy="548640"/>
+          </a:xfrm>
+          <a:prstGeom prst="rect">
+            <a:avLst/>
+          </a:prstGeom>
+          <a:noFill/>
+          <a:ln/>
+        </p:spPr>
+        <p:txBody>
+          <a:bodyPr wrap="square" lIns="0" tIns="0" rIns="0" bIns="0" rtlCol="0" anchor="ctr"/>
+          <a:lstStyle/>
+          <a:p>
+            <a:pPr indent="0" marL="0">
+              <a:lnSpc>
+                <a:spcPts val="2100"/>
+              </a:lnSpc>
+              <a:buNone/>
+            </a:pPr>
+            <a:r>
+              <a:rPr lang="en-US" sz="1500" dirty="0">
                 <a:solidFill>
                   <a:srgbClr val="22252E"/>
                 </a:solidFill>
@@ -3031,146 +3049,136 @@
                 <a:ea typeface="Calibri" pitchFamily="34" charset="-122"/>
                 <a:cs typeface="Calibri" pitchFamily="34" charset="-120"/>
               </a:rPr>
-              <a:t>American officials said the campaign "did not fit the pattern of a traditional cyber espionage campaign."</a:t>
-            </a:r>
-            <a:endParaRPr lang="en-US" sz="1400" dirty="0"/>
-          </a:p>
-        </p:txBody>
-      </p:sp>
-      <p:sp>
-        <p:nvSpPr>
-          <p:cNvPr id="9" name="Shape 7"/>
-          <p:cNvSpPr/>
-          <p:nvPr/>
-        </p:nvSpPr>
-        <p:spPr>
-          <a:xfrm>
-            <a:off x="7086600" y="1298448"/>
-            <a:ext cx="4434840" cy="3931920"/>
-          </a:xfrm>
-          <a:prstGeom prst="roundRect">
-            <a:avLst>
-              <a:gd name="adj" fmla="val 1860"/>
-            </a:avLst>
-          </a:prstGeom>
-          <a:solidFill>
-            <a:srgbClr val="F4F6FB"/>
-          </a:solidFill>
-          <a:ln w="9525">
-            <a:solidFill>
-              <a:srgbClr val="E2E7F2"/>
-            </a:solidFill>
-            <a:prstDash val="solid"/>
-          </a:ln>
-        </p:spPr>
-      </p:sp>
-      <p:sp>
-        <p:nvSpPr>
-          <p:cNvPr id="10" name="Text 8"/>
-          <p:cNvSpPr/>
-          <p:nvPr/>
-        </p:nvSpPr>
-        <p:spPr>
-          <a:xfrm>
-            <a:off x="7269480" y="1280160"/>
-            <a:ext cx="822960" cy="960120"/>
-          </a:xfrm>
-          <a:prstGeom prst="rect">
-            <a:avLst/>
-          </a:prstGeom>
-          <a:noFill/>
-          <a:ln/>
-        </p:spPr>
-        <p:txBody>
-          <a:bodyPr wrap="square" lIns="0" tIns="0" rIns="0" bIns="0" rtlCol="0" anchor="ctr"/>
-          <a:lstStyle/>
-          <a:p>
-            <a:pPr indent="0" marL="0">
-              <a:buNone/>
-            </a:pPr>
-            <a:r>
-              <a:rPr lang="en-US" sz="5800" b="1" dirty="0">
-                <a:solidFill>
-                  <a:srgbClr val="CADCFC"/>
+              <a:t>In plainer words: when a state leaves code inside another country’s infrastructure, is that a message? And does artificial intelligence change what the message means?</a:t>
+            </a:r>
+            <a:endParaRPr lang="en-US" sz="1500" dirty="0"/>
+          </a:p>
+        </p:txBody>
+      </p:sp>
+      <p:sp>
+        <p:nvSpPr>
+          <p:cNvPr id="7" name="Text 5"/>
+          <p:cNvSpPr/>
+          <p:nvPr/>
+        </p:nvSpPr>
+        <p:spPr>
+          <a:xfrm>
+            <a:off x="640080" y="3529584"/>
+            <a:ext cx="5486400" cy="329184"/>
+          </a:xfrm>
+          <a:prstGeom prst="rect">
+            <a:avLst/>
+          </a:prstGeom>
+          <a:noFill/>
+          <a:ln/>
+        </p:spPr>
+        <p:txBody>
+          <a:bodyPr wrap="square" lIns="0" tIns="0" rIns="0" bIns="0" rtlCol="0" anchor="ctr"/>
+          <a:lstStyle/>
+          <a:p>
+            <a:pPr indent="0" marL="0">
+              <a:buNone/>
+            </a:pPr>
+            <a:r>
+              <a:rPr lang="en-US" sz="1800" b="1" dirty="0">
+                <a:solidFill>
+                  <a:srgbClr val="1E2761"/>
                 </a:solidFill>
                 <a:latin typeface="Cambria" pitchFamily="34" charset="0"/>
                 <a:ea typeface="Cambria" pitchFamily="34" charset="-122"/>
                 <a:cs typeface="Cambria" pitchFamily="34" charset="-120"/>
               </a:rPr>
-              <a:t>“</a:t>
-            </a:r>
-            <a:endParaRPr lang="en-US" sz="5800" dirty="0"/>
-          </a:p>
-        </p:txBody>
-      </p:sp>
-      <p:sp>
-        <p:nvSpPr>
-          <p:cNvPr id="11" name="Text 9"/>
-          <p:cNvSpPr/>
-          <p:nvPr/>
-        </p:nvSpPr>
-        <p:spPr>
-          <a:xfrm>
-            <a:off x="7360920" y="1965960"/>
-            <a:ext cx="3886200" cy="1737360"/>
-          </a:xfrm>
-          <a:prstGeom prst="rect">
-            <a:avLst/>
-          </a:prstGeom>
-          <a:noFill/>
-          <a:ln/>
-        </p:spPr>
-        <p:txBody>
-          <a:bodyPr wrap="square" lIns="0" tIns="0" rIns="0" bIns="0" rtlCol="0" anchor="ctr"/>
-          <a:lstStyle/>
-          <a:p>
-            <a:pPr indent="0" marL="0">
-              <a:lnSpc>
-                <a:spcPts val="2500"/>
-              </a:lnSpc>
-              <a:buNone/>
-            </a:pPr>
-            <a:r>
-              <a:rPr lang="en-US" sz="1650" i="1" dirty="0">
-                <a:solidFill>
-                  <a:srgbClr val="1E2761"/>
+              <a:t>Five objectives</a:t>
+            </a:r>
+            <a:endParaRPr lang="en-US" sz="1800" dirty="0"/>
+          </a:p>
+        </p:txBody>
+      </p:sp>
+      <p:sp>
+        <p:nvSpPr>
+          <p:cNvPr id="8" name="Shape 6"/>
+          <p:cNvSpPr/>
+          <p:nvPr/>
+        </p:nvSpPr>
+        <p:spPr>
+          <a:xfrm>
+            <a:off x="640080" y="3931920"/>
+            <a:ext cx="365760" cy="365760"/>
+          </a:xfrm>
+          <a:prstGeom prst="ellipse">
+            <a:avLst/>
+          </a:prstGeom>
+          <a:solidFill>
+            <a:srgbClr val="1E2761"/>
+          </a:solidFill>
+          <a:ln/>
+        </p:spPr>
+      </p:sp>
+      <p:sp>
+        <p:nvSpPr>
+          <p:cNvPr id="9" name="Text 7"/>
+          <p:cNvSpPr/>
+          <p:nvPr/>
+        </p:nvSpPr>
+        <p:spPr>
+          <a:xfrm>
+            <a:off x="640080" y="3931920"/>
+            <a:ext cx="365760" cy="365760"/>
+          </a:xfrm>
+          <a:prstGeom prst="rect">
+            <a:avLst/>
+          </a:prstGeom>
+          <a:noFill/>
+          <a:ln/>
+        </p:spPr>
+        <p:txBody>
+          <a:bodyPr wrap="square" lIns="0" tIns="0" rIns="0" bIns="0" rtlCol="0" anchor="ctr"/>
+          <a:lstStyle/>
+          <a:p>
+            <a:pPr algn="ctr" indent="0" marL="0">
+              <a:buNone/>
+            </a:pPr>
+            <a:r>
+              <a:rPr lang="en-US" sz="1300" b="1" dirty="0">
+                <a:solidFill>
+                  <a:srgbClr val="FFFFFF"/>
                 </a:solidFill>
                 <a:latin typeface="Cambria" pitchFamily="34" charset="0"/>
                 <a:ea typeface="Cambria" pitchFamily="34" charset="-122"/>
                 <a:cs typeface="Cambria" pitchFamily="34" charset="-120"/>
               </a:rPr>
-              <a:t>There is absolutely no intelligence to be gathered by putting malicious code in critical infrastructure networks.</a:t>
-            </a:r>
-            <a:endParaRPr lang="en-US" sz="1650" dirty="0"/>
-          </a:p>
-        </p:txBody>
-      </p:sp>
-      <p:sp>
-        <p:nvSpPr>
-          <p:cNvPr id="12" name="Text 10"/>
-          <p:cNvSpPr/>
-          <p:nvPr/>
-        </p:nvSpPr>
-        <p:spPr>
-          <a:xfrm>
-            <a:off x="7360920" y="3886200"/>
-            <a:ext cx="3886200" cy="256032"/>
-          </a:xfrm>
-          <a:prstGeom prst="rect">
-            <a:avLst/>
-          </a:prstGeom>
-          <a:noFill/>
-          <a:ln/>
-        </p:spPr>
-        <p:txBody>
-          <a:bodyPr wrap="square" lIns="0" tIns="0" rIns="0" bIns="0" rtlCol="0" anchor="ctr"/>
-          <a:lstStyle/>
-          <a:p>
-            <a:pPr indent="0" marL="0">
-              <a:buNone/>
-            </a:pPr>
-            <a:r>
-              <a:rPr lang="en-US" sz="1300" b="1" dirty="0">
+              <a:t>1</a:t>
+            </a:r>
+            <a:endParaRPr lang="en-US" sz="1300" dirty="0"/>
+          </a:p>
+        </p:txBody>
+      </p:sp>
+      <p:sp>
+        <p:nvSpPr>
+          <p:cNvPr id="10" name="Text 8"/>
+          <p:cNvSpPr/>
+          <p:nvPr/>
+        </p:nvSpPr>
+        <p:spPr>
+          <a:xfrm>
+            <a:off x="1207008" y="3913632"/>
+            <a:ext cx="10332720" cy="411480"/>
+          </a:xfrm>
+          <a:prstGeom prst="rect">
+            <a:avLst/>
+          </a:prstGeom>
+          <a:noFill/>
+          <a:ln/>
+        </p:spPr>
+        <p:txBody>
+          <a:bodyPr wrap="square" lIns="0" tIns="0" rIns="0" bIns="0" rtlCol="0" anchor="ctr"/>
+          <a:lstStyle/>
+          <a:p>
+            <a:pPr indent="0" marL="0">
+              <a:buNone/>
+            </a:pPr>
+            <a:r>
+              <a:rPr lang="en-US" sz="1400" dirty="0">
                 <a:solidFill>
                   <a:srgbClr val="22252E"/>
                 </a:solidFill>
@@ -3178,7 +3186,66 @@
                 <a:ea typeface="Calibri" pitchFamily="34" charset="-122"/>
                 <a:cs typeface="Calibri" pitchFamily="34" charset="-120"/>
               </a:rPr>
-              <a:t>General Paul Nakasone</a:t>
+              <a:t>To set out how the literature tells spying apart from signalling.</a:t>
+            </a:r>
+            <a:endParaRPr lang="en-US" sz="1400" dirty="0"/>
+          </a:p>
+        </p:txBody>
+      </p:sp>
+      <p:sp>
+        <p:nvSpPr>
+          <p:cNvPr id="11" name="Shape 9"/>
+          <p:cNvSpPr/>
+          <p:nvPr/>
+        </p:nvSpPr>
+        <p:spPr>
+          <a:xfrm>
+            <a:off x="640080" y="4416552"/>
+            <a:ext cx="365760" cy="365760"/>
+          </a:xfrm>
+          <a:prstGeom prst="ellipse">
+            <a:avLst/>
+          </a:prstGeom>
+          <a:solidFill>
+            <a:srgbClr val="1E2761"/>
+          </a:solidFill>
+          <a:ln/>
+        </p:spPr>
+      </p:sp>
+      <p:sp>
+        <p:nvSpPr>
+          <p:cNvPr id="12" name="Text 10"/>
+          <p:cNvSpPr/>
+          <p:nvPr/>
+        </p:nvSpPr>
+        <p:spPr>
+          <a:xfrm>
+            <a:off x="640080" y="4416552"/>
+            <a:ext cx="365760" cy="365760"/>
+          </a:xfrm>
+          <a:prstGeom prst="rect">
+            <a:avLst/>
+          </a:prstGeom>
+          <a:noFill/>
+          <a:ln/>
+        </p:spPr>
+        <p:txBody>
+          <a:bodyPr wrap="square" lIns="0" tIns="0" rIns="0" bIns="0" rtlCol="0" anchor="ctr"/>
+          <a:lstStyle/>
+          <a:p>
+            <a:pPr algn="ctr" indent="0" marL="0">
+              <a:buNone/>
+            </a:pPr>
+            <a:r>
+              <a:rPr lang="en-US" sz="1300" b="1" dirty="0">
+                <a:solidFill>
+                  <a:srgbClr val="FFFFFF"/>
+                </a:solidFill>
+                <a:latin typeface="Cambria" pitchFamily="34" charset="0"/>
+                <a:ea typeface="Cambria" pitchFamily="34" charset="-122"/>
+                <a:cs typeface="Cambria" pitchFamily="34" charset="-120"/>
+              </a:rPr>
+              <a:t>2</a:t>
             </a:r>
             <a:endParaRPr lang="en-US" sz="1300" dirty="0"/>
           </a:p>
@@ -3192,34 +3259,34 @@
         </p:nvSpPr>
         <p:spPr>
           <a:xfrm>
-            <a:off x="7360920" y="4133088"/>
-            <a:ext cx="3886200" cy="256032"/>
-          </a:xfrm>
-          <a:prstGeom prst="rect">
-            <a:avLst/>
-          </a:prstGeom>
-          <a:noFill/>
-          <a:ln/>
-        </p:spPr>
-        <p:txBody>
-          <a:bodyPr wrap="square" lIns="0" tIns="0" rIns="0" bIns="0" rtlCol="0" anchor="ctr"/>
-          <a:lstStyle/>
-          <a:p>
-            <a:pPr indent="0" marL="0">
-              <a:buNone/>
-            </a:pPr>
-            <a:r>
-              <a:rPr lang="en-US" sz="1200" dirty="0">
-                <a:solidFill>
-                  <a:srgbClr val="6A6F7D"/>
+            <a:off x="1207008" y="4398264"/>
+            <a:ext cx="10332720" cy="411480"/>
+          </a:xfrm>
+          <a:prstGeom prst="rect">
+            <a:avLst/>
+          </a:prstGeom>
+          <a:noFill/>
+          <a:ln/>
+        </p:spPr>
+        <p:txBody>
+          <a:bodyPr wrap="square" lIns="0" tIns="0" rIns="0" bIns="0" rtlCol="0" anchor="ctr"/>
+          <a:lstStyle/>
+          <a:p>
+            <a:pPr indent="0" marL="0">
+              <a:buNone/>
+            </a:pPr>
+            <a:r>
+              <a:rPr lang="en-US" sz="1400" dirty="0">
+                <a:solidFill>
+                  <a:srgbClr val="22252E"/>
                 </a:solidFill>
                 <a:latin typeface="Calibri" pitchFamily="34" charset="0"/>
                 <a:ea typeface="Calibri" pitchFamily="34" charset="-122"/>
                 <a:cs typeface="Calibri" pitchFamily="34" charset="-120"/>
               </a:rPr>
-              <a:t>Then head of US Cyber Command</a:t>
-            </a:r>
-            <a:endParaRPr lang="en-US" sz="1200" dirty="0"/>
+              <a:t>To find the assumptions about cost that this distinction depends on.</a:t>
+            </a:r>
+            <a:endParaRPr lang="en-US" sz="1400" dirty="0"/>
           </a:p>
         </p:txBody>
       </p:sp>
@@ -3231,23 +3298,16 @@
         </p:nvSpPr>
         <p:spPr>
           <a:xfrm>
-            <a:off x="640080" y="5413248"/>
-            <a:ext cx="10881360" cy="1051560"/>
-          </a:xfrm>
-          <a:prstGeom prst="roundRect">
-            <a:avLst>
-              <a:gd name="adj" fmla="val 6957"/>
-            </a:avLst>
+            <a:off x="640080" y="4901184"/>
+            <a:ext cx="365760" cy="365760"/>
+          </a:xfrm>
+          <a:prstGeom prst="ellipse">
+            <a:avLst/>
           </a:prstGeom>
           <a:solidFill>
-            <a:srgbClr val="F4F6FB"/>
+            <a:srgbClr val="1E2761"/>
           </a:solidFill>
-          <a:ln w="9525">
-            <a:solidFill>
-              <a:srgbClr val="E2E7F2"/>
-            </a:solidFill>
-            <a:prstDash val="solid"/>
-          </a:ln>
+          <a:ln/>
         </p:spPr>
       </p:sp>
       <p:sp>
@@ -3258,34 +3318,34 @@
         </p:nvSpPr>
         <p:spPr>
           <a:xfrm>
-            <a:off x="1005840" y="5541264"/>
-            <a:ext cx="2743200" cy="292608"/>
-          </a:xfrm>
-          <a:prstGeom prst="rect">
-            <a:avLst/>
-          </a:prstGeom>
-          <a:noFill/>
-          <a:ln/>
-        </p:spPr>
-        <p:txBody>
-          <a:bodyPr wrap="square" lIns="0" tIns="0" rIns="0" bIns="0" rtlCol="0" anchor="ctr"/>
-          <a:lstStyle/>
-          <a:p>
-            <a:pPr indent="0" marL="0">
-              <a:buNone/>
-            </a:pPr>
-            <a:r>
-              <a:rPr lang="en-US" sz="1500" b="1" dirty="0">
-                <a:solidFill>
-                  <a:srgbClr val="1E2761"/>
+            <a:off x="640080" y="4901184"/>
+            <a:ext cx="365760" cy="365760"/>
+          </a:xfrm>
+          <a:prstGeom prst="rect">
+            <a:avLst/>
+          </a:prstGeom>
+          <a:noFill/>
+          <a:ln/>
+        </p:spPr>
+        <p:txBody>
+          <a:bodyPr wrap="square" lIns="0" tIns="0" rIns="0" bIns="0" rtlCol="0" anchor="ctr"/>
+          <a:lstStyle/>
+          <a:p>
+            <a:pPr algn="ctr" indent="0" marL="0">
+              <a:buNone/>
+            </a:pPr>
+            <a:r>
+              <a:rPr lang="en-US" sz="1300" b="1" dirty="0">
+                <a:solidFill>
+                  <a:srgbClr val="FFFFFF"/>
                 </a:solidFill>
                 <a:latin typeface="Cambria" pitchFamily="34" charset="0"/>
                 <a:ea typeface="Cambria" pitchFamily="34" charset="-122"/>
                 <a:cs typeface="Cambria" pitchFamily="34" charset="-120"/>
               </a:rPr>
-              <a:t>Where they were found</a:t>
-            </a:r>
-            <a:endParaRPr lang="en-US" sz="1500" dirty="0"/>
+              <a:t>3</a:t>
+            </a:r>
+            <a:endParaRPr lang="en-US" sz="1300" dirty="0"/>
           </a:p>
         </p:txBody>
       </p:sp>
@@ -3297,27 +3357,24 @@
         </p:nvSpPr>
         <p:spPr>
           <a:xfrm>
-            <a:off x="3840480" y="5504688"/>
-            <a:ext cx="7680960" cy="868680"/>
-          </a:xfrm>
-          <a:prstGeom prst="rect">
-            <a:avLst/>
-          </a:prstGeom>
-          <a:noFill/>
-          <a:ln/>
-        </p:spPr>
-        <p:txBody>
-          <a:bodyPr wrap="square" lIns="0" tIns="0" rIns="0" bIns="0" rtlCol="0" anchor="ctr"/>
-          <a:lstStyle/>
-          <a:p>
-            <a:pPr indent="0" marL="0">
-              <a:lnSpc>
-                <a:spcPts val="1800"/>
-              </a:lnSpc>
-              <a:buNone/>
-            </a:pPr>
-            <a:r>
-              <a:rPr lang="en-US" sz="1300" dirty="0">
+            <a:off x="1207008" y="4882896"/>
+            <a:ext cx="10332720" cy="411480"/>
+          </a:xfrm>
+          <a:prstGeom prst="rect">
+            <a:avLst/>
+          </a:prstGeom>
+          <a:noFill/>
+          <a:ln/>
+        </p:spPr>
+        <p:txBody>
+          <a:bodyPr wrap="square" lIns="0" tIns="0" rIns="0" bIns="0" rtlCol="0" anchor="ctr"/>
+          <a:lstStyle/>
+          <a:p>
+            <a:pPr indent="0" marL="0">
+              <a:buNone/>
+            </a:pPr>
+            <a:r>
+              <a:rPr lang="en-US" sz="1400" dirty="0">
                 <a:solidFill>
                   <a:srgbClr val="22252E"/>
                 </a:solidFill>
@@ -3325,9 +3382,205 @@
                 <a:ea typeface="Calibri" pitchFamily="34" charset="-122"/>
                 <a:cs typeface="Calibri" pitchFamily="34" charset="-120"/>
               </a:rPr>
-              <a:t>Energy, water, communications and transport networks, and in systems supporting American military operations on Guam, the logistics hub for any Pacific crisis. A target tied to one specific scenario, a conflict over Taiwan, says more about intent than a target chosen at random.</a:t>
+              <a:t>To assess where machine autonomy stands now and where it is heading.</a:t>
+            </a:r>
+            <a:endParaRPr lang="en-US" sz="1400" dirty="0"/>
+          </a:p>
+        </p:txBody>
+      </p:sp>
+      <p:sp>
+        <p:nvSpPr>
+          <p:cNvPr id="17" name="Shape 15"/>
+          <p:cNvSpPr/>
+          <p:nvPr/>
+        </p:nvSpPr>
+        <p:spPr>
+          <a:xfrm>
+            <a:off x="640080" y="5385816"/>
+            <a:ext cx="365760" cy="365760"/>
+          </a:xfrm>
+          <a:prstGeom prst="ellipse">
+            <a:avLst/>
+          </a:prstGeom>
+          <a:solidFill>
+            <a:srgbClr val="1E2761"/>
+          </a:solidFill>
+          <a:ln/>
+        </p:spPr>
+      </p:sp>
+      <p:sp>
+        <p:nvSpPr>
+          <p:cNvPr id="18" name="Text 16"/>
+          <p:cNvSpPr/>
+          <p:nvPr/>
+        </p:nvSpPr>
+        <p:spPr>
+          <a:xfrm>
+            <a:off x="640080" y="5385816"/>
+            <a:ext cx="365760" cy="365760"/>
+          </a:xfrm>
+          <a:prstGeom prst="rect">
+            <a:avLst/>
+          </a:prstGeom>
+          <a:noFill/>
+          <a:ln/>
+        </p:spPr>
+        <p:txBody>
+          <a:bodyPr wrap="square" lIns="0" tIns="0" rIns="0" bIns="0" rtlCol="0" anchor="ctr"/>
+          <a:lstStyle/>
+          <a:p>
+            <a:pPr algn="ctr" indent="0" marL="0">
+              <a:buNone/>
+            </a:pPr>
+            <a:r>
+              <a:rPr lang="en-US" sz="1300" b="1" dirty="0">
+                <a:solidFill>
+                  <a:srgbClr val="FFFFFF"/>
+                </a:solidFill>
+                <a:latin typeface="Cambria" pitchFamily="34" charset="0"/>
+                <a:ea typeface="Cambria" pitchFamily="34" charset="-122"/>
+                <a:cs typeface="Cambria" pitchFamily="34" charset="-120"/>
+              </a:rPr>
+              <a:t>4</a:t>
             </a:r>
             <a:endParaRPr lang="en-US" sz="1300" dirty="0"/>
+          </a:p>
+        </p:txBody>
+      </p:sp>
+      <p:sp>
+        <p:nvSpPr>
+          <p:cNvPr id="19" name="Text 17"/>
+          <p:cNvSpPr/>
+          <p:nvPr/>
+        </p:nvSpPr>
+        <p:spPr>
+          <a:xfrm>
+            <a:off x="1207008" y="5367528"/>
+            <a:ext cx="10332720" cy="411480"/>
+          </a:xfrm>
+          <a:prstGeom prst="rect">
+            <a:avLst/>
+          </a:prstGeom>
+          <a:noFill/>
+          <a:ln/>
+        </p:spPr>
+        <p:txBody>
+          <a:bodyPr wrap="square" lIns="0" tIns="0" rIns="0" bIns="0" rtlCol="0" anchor="ctr"/>
+          <a:lstStyle/>
+          <a:p>
+            <a:pPr indent="0" marL="0">
+              <a:buNone/>
+            </a:pPr>
+            <a:r>
+              <a:rPr lang="en-US" sz="1400" dirty="0">
+                <a:solidFill>
+                  <a:srgbClr val="22252E"/>
+                </a:solidFill>
+                <a:latin typeface="Calibri" pitchFamily="34" charset="0"/>
+                <a:ea typeface="Calibri" pitchFamily="34" charset="-122"/>
+                <a:cs typeface="Calibri" pitchFamily="34" charset="-120"/>
+              </a:rPr>
+              <a:t>To work out what happens to warning, escalation and stability if staying hidden becomes cheap.</a:t>
+            </a:r>
+            <a:endParaRPr lang="en-US" sz="1400" dirty="0"/>
+          </a:p>
+        </p:txBody>
+      </p:sp>
+      <p:sp>
+        <p:nvSpPr>
+          <p:cNvPr id="20" name="Shape 18"/>
+          <p:cNvSpPr/>
+          <p:nvPr/>
+        </p:nvSpPr>
+        <p:spPr>
+          <a:xfrm>
+            <a:off x="640080" y="5870448"/>
+            <a:ext cx="365760" cy="365760"/>
+          </a:xfrm>
+          <a:prstGeom prst="ellipse">
+            <a:avLst/>
+          </a:prstGeom>
+          <a:solidFill>
+            <a:srgbClr val="1E2761"/>
+          </a:solidFill>
+          <a:ln/>
+        </p:spPr>
+      </p:sp>
+      <p:sp>
+        <p:nvSpPr>
+          <p:cNvPr id="21" name="Text 19"/>
+          <p:cNvSpPr/>
+          <p:nvPr/>
+        </p:nvSpPr>
+        <p:spPr>
+          <a:xfrm>
+            <a:off x="640080" y="5870448"/>
+            <a:ext cx="365760" cy="365760"/>
+          </a:xfrm>
+          <a:prstGeom prst="rect">
+            <a:avLst/>
+          </a:prstGeom>
+          <a:noFill/>
+          <a:ln/>
+        </p:spPr>
+        <p:txBody>
+          <a:bodyPr wrap="square" lIns="0" tIns="0" rIns="0" bIns="0" rtlCol="0" anchor="ctr"/>
+          <a:lstStyle/>
+          <a:p>
+            <a:pPr algn="ctr" indent="0" marL="0">
+              <a:buNone/>
+            </a:pPr>
+            <a:r>
+              <a:rPr lang="en-US" sz="1300" b="1" dirty="0">
+                <a:solidFill>
+                  <a:srgbClr val="FFFFFF"/>
+                </a:solidFill>
+                <a:latin typeface="Cambria" pitchFamily="34" charset="0"/>
+                <a:ea typeface="Cambria" pitchFamily="34" charset="-122"/>
+                <a:cs typeface="Cambria" pitchFamily="34" charset="-120"/>
+              </a:rPr>
+              <a:t>5</a:t>
+            </a:r>
+            <a:endParaRPr lang="en-US" sz="1300" dirty="0"/>
+          </a:p>
+        </p:txBody>
+      </p:sp>
+      <p:sp>
+        <p:nvSpPr>
+          <p:cNvPr id="22" name="Text 20"/>
+          <p:cNvSpPr/>
+          <p:nvPr/>
+        </p:nvSpPr>
+        <p:spPr>
+          <a:xfrm>
+            <a:off x="1207008" y="5852160"/>
+            <a:ext cx="10332720" cy="411480"/>
+          </a:xfrm>
+          <a:prstGeom prst="rect">
+            <a:avLst/>
+          </a:prstGeom>
+          <a:noFill/>
+          <a:ln/>
+        </p:spPr>
+        <p:txBody>
+          <a:bodyPr wrap="square" lIns="0" tIns="0" rIns="0" bIns="0" rtlCol="0" anchor="ctr"/>
+          <a:lstStyle/>
+          <a:p>
+            <a:pPr indent="0" marL="0">
+              <a:buNone/>
+            </a:pPr>
+            <a:r>
+              <a:rPr lang="en-US" sz="1400" dirty="0">
+                <a:solidFill>
+                  <a:srgbClr val="22252E"/>
+                </a:solidFill>
+                <a:latin typeface="Calibri" pitchFamily="34" charset="0"/>
+                <a:ea typeface="Calibri" pitchFamily="34" charset="-122"/>
+                <a:cs typeface="Calibri" pitchFamily="34" charset="-120"/>
+              </a:rPr>
+              <a:t>To suggest signs by which analysts could spot that change.</a:t>
+            </a:r>
+            <a:endParaRPr lang="en-US" sz="1400" dirty="0"/>
           </a:p>
         </p:txBody>
       </p:sp>
@@ -3396,7 +3649,7 @@
                 <a:ea typeface="Calibri" pitchFamily="34" charset="-122"/>
                 <a:cs typeface="Calibri" pitchFamily="34" charset="-120"/>
               </a:rPr>
-              <a:t>THE VULNERABILITY</a:t>
+              <a:t>THE EVIDENCE</a:t>
             </a:r>
             <a:endParaRPr lang="en-US" sz="1200" dirty="0"/>
           </a:p>
@@ -3435,7 +3688,7 @@
                 <a:ea typeface="Cambria" pitchFamily="34" charset="-122"/>
                 <a:cs typeface="Cambria" pitchFamily="34" charset="-120"/>
               </a:rPr>
-              <a:t>How an intruder stays inside for years</a:t>
+              <a:t>The case that raises the question</a:t>
             </a:r>
             <a:endParaRPr lang="en-US" sz="3000" dirty="0"/>
           </a:p>
@@ -3443,23 +3696,96 @@
       </p:sp>
       <p:sp>
         <p:nvSpPr>
-          <p:cNvPr id="4" name="Shape 2"/>
-          <p:cNvSpPr/>
-          <p:nvPr/>
-        </p:nvSpPr>
-        <p:spPr>
-          <a:xfrm>
-            <a:off x="640080" y="1335024"/>
-            <a:ext cx="502920" cy="502920"/>
-          </a:xfrm>
-          <a:prstGeom prst="ellipse">
-            <a:avLst/>
-          </a:prstGeom>
-          <a:solidFill>
-            <a:srgbClr val="1E2761"/>
-          </a:solidFill>
-          <a:ln/>
-        </p:spPr>
+          <p:cNvPr id="4" name="Text 2"/>
+          <p:cNvSpPr/>
+          <p:nvPr/>
+        </p:nvSpPr>
+        <p:spPr>
+          <a:xfrm>
+            <a:off x="640080" y="1280160"/>
+            <a:ext cx="6035040" cy="1371600"/>
+          </a:xfrm>
+          <a:prstGeom prst="rect">
+            <a:avLst/>
+          </a:prstGeom>
+          <a:noFill/>
+          <a:ln/>
+        </p:spPr>
+        <p:txBody>
+          <a:bodyPr wrap="square" lIns="0" tIns="0" rIns="0" bIns="0" rtlCol="0" anchor="ctr"/>
+          <a:lstStyle/>
+          <a:p>
+            <a:pPr indent="0" marL="0">
+              <a:lnSpc>
+                <a:spcPts val="2200"/>
+              </a:lnSpc>
+              <a:buNone/>
+            </a:pPr>
+            <a:r>
+              <a:rPr lang="en-US" sz="1550" b="1" dirty="0">
+                <a:solidFill>
+                  <a:srgbClr val="22252E"/>
+                </a:solidFill>
+                <a:latin typeface="Calibri" pitchFamily="34" charset="0"/>
+                <a:ea typeface="Calibri" pitchFamily="34" charset="-122"/>
+                <a:cs typeface="Calibri" pitchFamily="34" charset="-120"/>
+              </a:rPr>
+              <a:t>May 2023.</a:t>
+            </a:r>
+            <a:pPr indent="0" marL="0">
+              <a:lnSpc>
+                <a:spcPts val="2200"/>
+              </a:lnSpc>
+              <a:buNone/>
+            </a:pPr>
+            <a:r>
+              <a:rPr lang="en-US" sz="1550" dirty="0">
+                <a:solidFill>
+                  <a:srgbClr val="22252E"/>
+                </a:solidFill>
+                <a:latin typeface="Calibri" pitchFamily="34" charset="0"/>
+                <a:ea typeface="Calibri" pitchFamily="34" charset="-122"/>
+                <a:cs typeface="Calibri" pitchFamily="34" charset="-120"/>
+              </a:rPr>
+              <a:t> The United States and its Five Eyes partners named China as the source of a campaign called </a:t>
+            </a:r>
+            <a:pPr indent="0" marL="0">
+              <a:lnSpc>
+                <a:spcPts val="2200"/>
+              </a:lnSpc>
+              <a:buNone/>
+            </a:pPr>
+            <a:r>
+              <a:rPr lang="en-US" sz="1550" b="1" dirty="0">
+                <a:solidFill>
+                  <a:srgbClr val="22252E"/>
+                </a:solidFill>
+                <a:latin typeface="Calibri" pitchFamily="34" charset="0"/>
+                <a:ea typeface="Calibri" pitchFamily="34" charset="-122"/>
+                <a:cs typeface="Calibri" pitchFamily="34" charset="-120"/>
+              </a:rPr>
+              <a:t>Volt Typhoon</a:t>
+            </a:r>
+            <a:pPr indent="0" marL="0">
+              <a:lnSpc>
+                <a:spcPts val="2200"/>
+              </a:lnSpc>
+              <a:buNone/>
+            </a:pPr>
+            <a:r>
+              <a:rPr lang="en-US" sz="1550" dirty="0">
+                <a:solidFill>
+                  <a:srgbClr val="22252E"/>
+                </a:solidFill>
+                <a:latin typeface="Calibri" pitchFamily="34" charset="0"/>
+                <a:ea typeface="Calibri" pitchFamily="34" charset="-122"/>
+                <a:cs typeface="Calibri" pitchFamily="34" charset="-120"/>
+              </a:rPr>
+              <a:t>. Operators had been living inside American energy, water, communications and transport networks, and in systems supporting military operations on Guam.</a:t>
+            </a:r>
+            <a:endParaRPr lang="en-US" sz="1550" dirty="0"/>
+          </a:p>
+        </p:txBody>
       </p:sp>
       <p:sp>
         <p:nvSpPr>
@@ -3469,34 +3795,34 @@
         </p:nvSpPr>
         <p:spPr>
           <a:xfrm>
-            <a:off x="640080" y="1335024"/>
-            <a:ext cx="502920" cy="502920"/>
-          </a:xfrm>
-          <a:prstGeom prst="rect">
-            <a:avLst/>
-          </a:prstGeom>
-          <a:noFill/>
-          <a:ln/>
-        </p:spPr>
-        <p:txBody>
-          <a:bodyPr wrap="square" lIns="0" tIns="0" rIns="0" bIns="0" rtlCol="0" anchor="ctr"/>
-          <a:lstStyle/>
-          <a:p>
-            <a:pPr algn="ctr" indent="0" marL="0">
-              <a:buNone/>
-            </a:pPr>
-            <a:r>
-              <a:rPr lang="en-US" sz="1300" b="1" dirty="0">
-                <a:solidFill>
-                  <a:srgbClr val="FFFFFF"/>
+            <a:off x="640080" y="2761488"/>
+            <a:ext cx="6035040" cy="365760"/>
+          </a:xfrm>
+          <a:prstGeom prst="rect">
+            <a:avLst/>
+          </a:prstGeom>
+          <a:noFill/>
+          <a:ln/>
+        </p:spPr>
+        <p:txBody>
+          <a:bodyPr wrap="square" lIns="0" tIns="0" rIns="0" bIns="0" rtlCol="0" anchor="ctr"/>
+          <a:lstStyle/>
+          <a:p>
+            <a:pPr indent="0" marL="0">
+              <a:buNone/>
+            </a:pPr>
+            <a:r>
+              <a:rPr lang="en-US" sz="2200" b="1" dirty="0">
+                <a:solidFill>
+                  <a:srgbClr val="1E2761"/>
                 </a:solidFill>
                 <a:latin typeface="Cambria" pitchFamily="34" charset="0"/>
                 <a:ea typeface="Cambria" pitchFamily="34" charset="-122"/>
                 <a:cs typeface="Cambria" pitchFamily="34" charset="-120"/>
               </a:rPr>
-              <a:t>1</a:t>
-            </a:r>
-            <a:endParaRPr lang="en-US" sz="1300" dirty="0"/>
+              <a:t>They took almost nothing.</a:t>
+            </a:r>
+            <a:endParaRPr lang="en-US" sz="2200" dirty="0"/>
           </a:p>
         </p:txBody>
       </p:sp>
@@ -3508,47 +3834,8 @@
         </p:nvSpPr>
         <p:spPr>
           <a:xfrm>
-            <a:off x="1417320" y="1298448"/>
-            <a:ext cx="10104120" cy="329184"/>
-          </a:xfrm>
-          <a:prstGeom prst="rect">
-            <a:avLst/>
-          </a:prstGeom>
-          <a:noFill/>
-          <a:ln/>
-        </p:spPr>
-        <p:txBody>
-          <a:bodyPr wrap="square" lIns="0" tIns="0" rIns="0" bIns="0" rtlCol="0" anchor="ctr"/>
-          <a:lstStyle/>
-          <a:p>
-            <a:pPr indent="0" marL="0">
-              <a:buNone/>
-            </a:pPr>
-            <a:r>
-              <a:rPr lang="en-US" sz="1750" b="1" dirty="0">
-                <a:solidFill>
-                  <a:srgbClr val="1E2761"/>
-                </a:solidFill>
-                <a:latin typeface="Cambria" pitchFamily="34" charset="0"/>
-                <a:ea typeface="Cambria" pitchFamily="34" charset="-122"/>
-                <a:cs typeface="Cambria" pitchFamily="34" charset="-120"/>
-              </a:rPr>
-              <a:t>They use your own tools</a:t>
-            </a:r>
-            <a:endParaRPr lang="en-US" sz="1750" dirty="0"/>
-          </a:p>
-        </p:txBody>
-      </p:sp>
-      <p:sp>
-        <p:nvSpPr>
-          <p:cNvPr id="7" name="Text 5"/>
-          <p:cNvSpPr/>
-          <p:nvPr/>
-        </p:nvSpPr>
-        <p:spPr>
-          <a:xfrm>
-            <a:off x="1417320" y="1645920"/>
-            <a:ext cx="10104120" cy="749808"/>
+            <a:off x="640080" y="3145536"/>
+            <a:ext cx="6035040" cy="548640"/>
           </a:xfrm>
           <a:prstGeom prst="rect">
             <a:avLst/>
@@ -3567,314 +3854,34 @@
               <a:buNone/>
             </a:pPr>
             <a:r>
-              <a:rPr lang="en-US" sz="1400" dirty="0">
-                <a:solidFill>
-                  <a:srgbClr val="22252E"/>
+              <a:rPr lang="en-US" sz="1450" dirty="0">
+                <a:solidFill>
+                  <a:srgbClr val="6A6F7D"/>
                 </a:solidFill>
                 <a:latin typeface="Calibri" pitchFamily="34" charset="0"/>
                 <a:ea typeface="Calibri" pitchFamily="34" charset="-122"/>
                 <a:cs typeface="Calibri" pitchFamily="34" charset="-120"/>
               </a:rPr>
-              <a:t>Rather than installing malware that security software would spot, the operators use the system’s own built-in utilities. Nothing looks out of place, because nothing foreign is running.</a:t>
-            </a:r>
-            <a:endParaRPr lang="en-US" sz="1400" dirty="0"/>
-          </a:p>
-        </p:txBody>
-      </p:sp>
-      <p:sp>
-        <p:nvSpPr>
-          <p:cNvPr id="8" name="Shape 6"/>
-          <p:cNvSpPr/>
-          <p:nvPr/>
-        </p:nvSpPr>
-        <p:spPr>
-          <a:xfrm>
-            <a:off x="640080" y="2542032"/>
-            <a:ext cx="502920" cy="502920"/>
-          </a:xfrm>
-          <a:prstGeom prst="ellipse">
-            <a:avLst/>
-          </a:prstGeom>
-          <a:solidFill>
-            <a:srgbClr val="1E2761"/>
-          </a:solidFill>
-          <a:ln/>
-        </p:spPr>
-      </p:sp>
-      <p:sp>
-        <p:nvSpPr>
-          <p:cNvPr id="9" name="Text 7"/>
-          <p:cNvSpPr/>
-          <p:nvPr/>
-        </p:nvSpPr>
-        <p:spPr>
-          <a:xfrm>
-            <a:off x="640080" y="2542032"/>
-            <a:ext cx="502920" cy="502920"/>
-          </a:xfrm>
-          <a:prstGeom prst="rect">
-            <a:avLst/>
-          </a:prstGeom>
-          <a:noFill/>
-          <a:ln/>
-        </p:spPr>
-        <p:txBody>
-          <a:bodyPr wrap="square" lIns="0" tIns="0" rIns="0" bIns="0" rtlCol="0" anchor="ctr"/>
-          <a:lstStyle/>
-          <a:p>
-            <a:pPr algn="ctr" indent="0" marL="0">
-              <a:buNone/>
-            </a:pPr>
-            <a:r>
-              <a:rPr lang="en-US" sz="1300" b="1" dirty="0">
-                <a:solidFill>
-                  <a:srgbClr val="FFFFFF"/>
-                </a:solidFill>
-                <a:latin typeface="Cambria" pitchFamily="34" charset="0"/>
-                <a:ea typeface="Cambria" pitchFamily="34" charset="-122"/>
-                <a:cs typeface="Cambria" pitchFamily="34" charset="-120"/>
-              </a:rPr>
-              <a:t>2</a:t>
-            </a:r>
-            <a:endParaRPr lang="en-US" sz="1300" dirty="0"/>
-          </a:p>
-        </p:txBody>
-      </p:sp>
-      <p:sp>
-        <p:nvSpPr>
-          <p:cNvPr id="10" name="Text 8"/>
-          <p:cNvSpPr/>
-          <p:nvPr/>
-        </p:nvSpPr>
-        <p:spPr>
-          <a:xfrm>
-            <a:off x="1417320" y="2505456"/>
-            <a:ext cx="10104120" cy="329184"/>
-          </a:xfrm>
-          <a:prstGeom prst="rect">
-            <a:avLst/>
-          </a:prstGeom>
-          <a:noFill/>
-          <a:ln/>
-        </p:spPr>
-        <p:txBody>
-          <a:bodyPr wrap="square" lIns="0" tIns="0" rIns="0" bIns="0" rtlCol="0" anchor="ctr"/>
-          <a:lstStyle/>
-          <a:p>
-            <a:pPr indent="0" marL="0">
-              <a:buNone/>
-            </a:pPr>
-            <a:r>
-              <a:rPr lang="en-US" sz="1750" b="1" dirty="0">
-                <a:solidFill>
-                  <a:srgbClr val="1E2761"/>
-                </a:solidFill>
-                <a:latin typeface="Cambria" pitchFamily="34" charset="0"/>
-                <a:ea typeface="Cambria" pitchFamily="34" charset="-122"/>
-                <a:cs typeface="Cambria" pitchFamily="34" charset="-120"/>
-              </a:rPr>
-              <a:t>Detection takes about six months</a:t>
-            </a:r>
-            <a:endParaRPr lang="en-US" sz="1750" dirty="0"/>
-          </a:p>
-        </p:txBody>
-      </p:sp>
-      <p:sp>
-        <p:nvSpPr>
-          <p:cNvPr id="11" name="Text 9"/>
-          <p:cNvSpPr/>
-          <p:nvPr/>
-        </p:nvSpPr>
-        <p:spPr>
-          <a:xfrm>
-            <a:off x="1417320" y="2852928"/>
-            <a:ext cx="10104120" cy="749808"/>
-          </a:xfrm>
-          <a:prstGeom prst="rect">
-            <a:avLst/>
-          </a:prstGeom>
-          <a:noFill/>
-          <a:ln/>
-        </p:spPr>
-        <p:txBody>
-          <a:bodyPr wrap="square" lIns="0" tIns="0" rIns="0" bIns="0" rtlCol="0" anchor="ctr"/>
-          <a:lstStyle/>
-          <a:p>
-            <a:pPr indent="0" marL="0">
-              <a:lnSpc>
-                <a:spcPts val="2000"/>
-              </a:lnSpc>
-              <a:buNone/>
-            </a:pPr>
-            <a:r>
-              <a:rPr lang="en-US" sz="1400" dirty="0">
-                <a:solidFill>
-                  <a:srgbClr val="22252E"/>
-                </a:solidFill>
-                <a:latin typeface="Calibri" pitchFamily="34" charset="0"/>
-                <a:ea typeface="Calibri" pitchFamily="34" charset="-122"/>
-                <a:cs typeface="Calibri" pitchFamily="34" charset="-120"/>
-              </a:rPr>
-              <a:t>Across nation-state intrusions coded from 2020 to 2024, the average time between break-in and discovery was 197 days. In the Volt Typhoon case, access is described as lasting up to five years.</a:t>
-            </a:r>
-            <a:endParaRPr lang="en-US" sz="1400" dirty="0"/>
-          </a:p>
-        </p:txBody>
-      </p:sp>
-      <p:sp>
-        <p:nvSpPr>
-          <p:cNvPr id="12" name="Shape 10"/>
-          <p:cNvSpPr/>
-          <p:nvPr/>
-        </p:nvSpPr>
-        <p:spPr>
-          <a:xfrm>
-            <a:off x="640080" y="3749040"/>
-            <a:ext cx="502920" cy="502920"/>
-          </a:xfrm>
-          <a:prstGeom prst="ellipse">
-            <a:avLst/>
-          </a:prstGeom>
-          <a:solidFill>
-            <a:srgbClr val="1E2761"/>
-          </a:solidFill>
-          <a:ln/>
-        </p:spPr>
-      </p:sp>
-      <p:sp>
-        <p:nvSpPr>
-          <p:cNvPr id="13" name="Text 11"/>
-          <p:cNvSpPr/>
-          <p:nvPr/>
-        </p:nvSpPr>
-        <p:spPr>
-          <a:xfrm>
-            <a:off x="640080" y="3749040"/>
-            <a:ext cx="502920" cy="502920"/>
-          </a:xfrm>
-          <a:prstGeom prst="rect">
-            <a:avLst/>
-          </a:prstGeom>
-          <a:noFill/>
-          <a:ln/>
-        </p:spPr>
-        <p:txBody>
-          <a:bodyPr wrap="square" lIns="0" tIns="0" rIns="0" bIns="0" rtlCol="0" anchor="ctr"/>
-          <a:lstStyle/>
-          <a:p>
-            <a:pPr algn="ctr" indent="0" marL="0">
-              <a:buNone/>
-            </a:pPr>
-            <a:r>
-              <a:rPr lang="en-US" sz="1300" b="1" dirty="0">
-                <a:solidFill>
-                  <a:srgbClr val="FFFFFF"/>
-                </a:solidFill>
-                <a:latin typeface="Cambria" pitchFamily="34" charset="0"/>
-                <a:ea typeface="Cambria" pitchFamily="34" charset="-122"/>
-                <a:cs typeface="Cambria" pitchFamily="34" charset="-120"/>
-              </a:rPr>
-              <a:t>3</a:t>
-            </a:r>
-            <a:endParaRPr lang="en-US" sz="1300" dirty="0"/>
-          </a:p>
-        </p:txBody>
-      </p:sp>
-      <p:sp>
-        <p:nvSpPr>
-          <p:cNvPr id="14" name="Text 12"/>
-          <p:cNvSpPr/>
-          <p:nvPr/>
-        </p:nvSpPr>
-        <p:spPr>
-          <a:xfrm>
-            <a:off x="1417320" y="3712464"/>
-            <a:ext cx="10104120" cy="329184"/>
-          </a:xfrm>
-          <a:prstGeom prst="rect">
-            <a:avLst/>
-          </a:prstGeom>
-          <a:noFill/>
-          <a:ln/>
-        </p:spPr>
-        <p:txBody>
-          <a:bodyPr wrap="square" lIns="0" tIns="0" rIns="0" bIns="0" rtlCol="0" anchor="ctr"/>
-          <a:lstStyle/>
-          <a:p>
-            <a:pPr indent="0" marL="0">
-              <a:buNone/>
-            </a:pPr>
-            <a:r>
-              <a:rPr lang="en-US" sz="1750" b="1" dirty="0">
-                <a:solidFill>
-                  <a:srgbClr val="1E2761"/>
-                </a:solidFill>
-                <a:latin typeface="Cambria" pitchFamily="34" charset="0"/>
-                <a:ea typeface="Cambria" pitchFamily="34" charset="-122"/>
-                <a:cs typeface="Cambria" pitchFamily="34" charset="-120"/>
-              </a:rPr>
-              <a:t>Victims usually are not the ones who notice</a:t>
-            </a:r>
-            <a:endParaRPr lang="en-US" sz="1750" dirty="0"/>
-          </a:p>
-        </p:txBody>
-      </p:sp>
-      <p:sp>
-        <p:nvSpPr>
-          <p:cNvPr id="15" name="Text 13"/>
-          <p:cNvSpPr/>
-          <p:nvPr/>
-        </p:nvSpPr>
-        <p:spPr>
-          <a:xfrm>
-            <a:off x="1417320" y="4059936"/>
-            <a:ext cx="10104120" cy="749808"/>
-          </a:xfrm>
-          <a:prstGeom prst="rect">
-            <a:avLst/>
-          </a:prstGeom>
-          <a:noFill/>
-          <a:ln/>
-        </p:spPr>
-        <p:txBody>
-          <a:bodyPr wrap="square" lIns="0" tIns="0" rIns="0" bIns="0" rtlCol="0" anchor="ctr"/>
-          <a:lstStyle/>
-          <a:p>
-            <a:pPr indent="0" marL="0">
-              <a:lnSpc>
-                <a:spcPts val="2000"/>
-              </a:lnSpc>
-              <a:buNone/>
-            </a:pPr>
-            <a:r>
-              <a:rPr lang="en-US" sz="1400" dirty="0">
-                <a:solidFill>
-                  <a:srgbClr val="22252E"/>
-                </a:solidFill>
-                <a:latin typeface="Calibri" pitchFamily="34" charset="0"/>
-                <a:ea typeface="Calibri" pitchFamily="34" charset="-122"/>
-                <a:cs typeface="Calibri" pitchFamily="34" charset="-120"/>
-              </a:rPr>
-              <a:t>Roughly three quarters of these intrusions were first spotted by someone other than the victim: a government agency, a security vendor, or a partner organisation.</a:t>
-            </a:r>
-            <a:endParaRPr lang="en-US" sz="1400" dirty="0"/>
-          </a:p>
-        </p:txBody>
-      </p:sp>
-      <p:sp>
-        <p:nvSpPr>
-          <p:cNvPr id="16" name="Shape 14"/>
-          <p:cNvSpPr/>
-          <p:nvPr/>
-        </p:nvSpPr>
-        <p:spPr>
-          <a:xfrm>
-            <a:off x="640080" y="5029200"/>
-            <a:ext cx="10881360" cy="1097280"/>
+              <a:t>A spy steals and leaves. These operators arrived, settled in, and waited.</a:t>
+            </a:r>
+            <a:endParaRPr lang="en-US" sz="1450" dirty="0"/>
+          </a:p>
+        </p:txBody>
+      </p:sp>
+      <p:sp>
+        <p:nvSpPr>
+          <p:cNvPr id="7" name="Shape 5"/>
+          <p:cNvSpPr/>
+          <p:nvPr/>
+        </p:nvSpPr>
+        <p:spPr>
+          <a:xfrm>
+            <a:off x="640080" y="3703320"/>
+            <a:ext cx="6035040" cy="1600200"/>
           </a:xfrm>
           <a:prstGeom prst="roundRect">
             <a:avLst>
-              <a:gd name="adj" fmla="val 6667"/>
+              <a:gd name="adj" fmla="val 4571"/>
             </a:avLst>
           </a:prstGeom>
           <a:solidFill>
@@ -3890,53 +3897,122 @@
       </p:sp>
       <p:sp>
         <p:nvSpPr>
-          <p:cNvPr id="17" name="Text 15"/>
-          <p:cNvSpPr/>
-          <p:nvPr/>
-        </p:nvSpPr>
-        <p:spPr>
-          <a:xfrm>
-            <a:off x="1005840" y="5138928"/>
-            <a:ext cx="3017520" cy="292608"/>
-          </a:xfrm>
-          <a:prstGeom prst="rect">
-            <a:avLst/>
-          </a:prstGeom>
-          <a:noFill/>
-          <a:ln/>
-        </p:spPr>
-        <p:txBody>
-          <a:bodyPr wrap="square" lIns="0" tIns="0" rIns="0" bIns="0" rtlCol="0" anchor="ctr"/>
-          <a:lstStyle/>
-          <a:p>
-            <a:pPr indent="0" marL="0">
-              <a:buNone/>
-            </a:pPr>
-            <a:r>
-              <a:rPr lang="en-US" sz="1550" b="1" dirty="0">
-                <a:solidFill>
-                  <a:srgbClr val="D98C1F"/>
+          <p:cNvPr id="8" name="Text 6"/>
+          <p:cNvSpPr/>
+          <p:nvPr/>
+        </p:nvSpPr>
+        <p:spPr>
+          <a:xfrm>
+            <a:off x="960120" y="3913632"/>
+            <a:ext cx="5440680" cy="1188720"/>
+          </a:xfrm>
+          <a:prstGeom prst="rect">
+            <a:avLst/>
+          </a:prstGeom>
+          <a:noFill/>
+          <a:ln/>
+        </p:spPr>
+        <p:txBody>
+          <a:bodyPr wrap="square" lIns="0" tIns="0" rIns="0" bIns="0" rtlCol="0" anchor="ctr"/>
+          <a:lstStyle/>
+          <a:p>
+            <a:pPr indent="0" marL="0">
+              <a:lnSpc>
+                <a:spcPts val="2000"/>
+              </a:lnSpc>
+              <a:buNone/>
+            </a:pPr>
+            <a:r>
+              <a:rPr lang="en-US" sz="1400" i="1" dirty="0">
+                <a:solidFill>
+                  <a:srgbClr val="22252E"/>
+                </a:solidFill>
+                <a:latin typeface="Calibri" pitchFamily="34" charset="0"/>
+                <a:ea typeface="Calibri" pitchFamily="34" charset="-122"/>
+                <a:cs typeface="Calibri" pitchFamily="34" charset="-120"/>
+              </a:rPr>
+              <a:t>American officials said the campaign "did not fit the pattern of a traditional cyber espionage campaign."</a:t>
+            </a:r>
+            <a:endParaRPr lang="en-US" sz="1400" dirty="0"/>
+          </a:p>
+        </p:txBody>
+      </p:sp>
+      <p:sp>
+        <p:nvSpPr>
+          <p:cNvPr id="9" name="Shape 7"/>
+          <p:cNvSpPr/>
+          <p:nvPr/>
+        </p:nvSpPr>
+        <p:spPr>
+          <a:xfrm>
+            <a:off x="7086600" y="1280160"/>
+            <a:ext cx="4434840" cy="4023360"/>
+          </a:xfrm>
+          <a:prstGeom prst="roundRect">
+            <a:avLst>
+              <a:gd name="adj" fmla="val 1818"/>
+            </a:avLst>
+          </a:prstGeom>
+          <a:solidFill>
+            <a:srgbClr val="F4F6FB"/>
+          </a:solidFill>
+          <a:ln w="9525">
+            <a:solidFill>
+              <a:srgbClr val="E2E7F2"/>
+            </a:solidFill>
+            <a:prstDash val="solid"/>
+          </a:ln>
+        </p:spPr>
+      </p:sp>
+      <p:sp>
+        <p:nvSpPr>
+          <p:cNvPr id="10" name="Text 8"/>
+          <p:cNvSpPr/>
+          <p:nvPr/>
+        </p:nvSpPr>
+        <p:spPr>
+          <a:xfrm>
+            <a:off x="7269480" y="1261872"/>
+            <a:ext cx="822960" cy="960120"/>
+          </a:xfrm>
+          <a:prstGeom prst="rect">
+            <a:avLst/>
+          </a:prstGeom>
+          <a:noFill/>
+          <a:ln/>
+        </p:spPr>
+        <p:txBody>
+          <a:bodyPr wrap="square" lIns="0" tIns="0" rIns="0" bIns="0" rtlCol="0" anchor="ctr"/>
+          <a:lstStyle/>
+          <a:p>
+            <a:pPr indent="0" marL="0">
+              <a:buNone/>
+            </a:pPr>
+            <a:r>
+              <a:rPr lang="en-US" sz="5800" b="1" dirty="0">
+                <a:solidFill>
+                  <a:srgbClr val="CADCFC"/>
                 </a:solidFill>
                 <a:latin typeface="Cambria" pitchFamily="34" charset="0"/>
                 <a:ea typeface="Cambria" pitchFamily="34" charset="-122"/>
                 <a:cs typeface="Cambria" pitchFamily="34" charset="-120"/>
               </a:rPr>
-              <a:t>What that access buys</a:t>
-            </a:r>
-            <a:endParaRPr lang="en-US" sz="1550" dirty="0"/>
-          </a:p>
-        </p:txBody>
-      </p:sp>
-      <p:sp>
-        <p:nvSpPr>
-          <p:cNvPr id="18" name="Text 16"/>
-          <p:cNvSpPr/>
-          <p:nvPr/>
-        </p:nvSpPr>
-        <p:spPr>
-          <a:xfrm>
-            <a:off x="1005840" y="5449824"/>
-            <a:ext cx="10149840" cy="566928"/>
+              <a:t>“</a:t>
+            </a:r>
+            <a:endParaRPr lang="en-US" sz="5800" dirty="0"/>
+          </a:p>
+        </p:txBody>
+      </p:sp>
+      <p:sp>
+        <p:nvSpPr>
+          <p:cNvPr id="11" name="Text 9"/>
+          <p:cNvSpPr/>
+          <p:nvPr/>
+        </p:nvSpPr>
+        <p:spPr>
+          <a:xfrm>
+            <a:off x="7360920" y="1965960"/>
+            <a:ext cx="3886200" cy="1783080"/>
           </a:xfrm>
           <a:prstGeom prst="rect">
             <a:avLst/>
@@ -3950,12 +4026,51 @@
           <a:p>
             <a:pPr indent="0" marL="0">
               <a:lnSpc>
-                <a:spcPts val="1900"/>
+                <a:spcPts val="2500"/>
               </a:lnSpc>
               <a:buNone/>
             </a:pPr>
             <a:r>
-              <a:rPr lang="en-US" sz="1350" dirty="0">
+              <a:rPr lang="en-US" sz="1650" i="1" dirty="0">
+                <a:solidFill>
+                  <a:srgbClr val="1E2761"/>
+                </a:solidFill>
+                <a:latin typeface="Cambria" pitchFamily="34" charset="0"/>
+                <a:ea typeface="Cambria" pitchFamily="34" charset="-122"/>
+                <a:cs typeface="Cambria" pitchFamily="34" charset="-120"/>
+              </a:rPr>
+              <a:t>There is absolutely no intelligence to be gathered by putting malicious code in critical infrastructure networks.</a:t>
+            </a:r>
+            <a:endParaRPr lang="en-US" sz="1650" dirty="0"/>
+          </a:p>
+        </p:txBody>
+      </p:sp>
+      <p:sp>
+        <p:nvSpPr>
+          <p:cNvPr id="12" name="Text 10"/>
+          <p:cNvSpPr/>
+          <p:nvPr/>
+        </p:nvSpPr>
+        <p:spPr>
+          <a:xfrm>
+            <a:off x="7360920" y="3950208"/>
+            <a:ext cx="3886200" cy="256032"/>
+          </a:xfrm>
+          <a:prstGeom prst="rect">
+            <a:avLst/>
+          </a:prstGeom>
+          <a:noFill/>
+          <a:ln/>
+        </p:spPr>
+        <p:txBody>
+          <a:bodyPr wrap="square" lIns="0" tIns="0" rIns="0" bIns="0" rtlCol="0" anchor="ctr"/>
+          <a:lstStyle/>
+          <a:p>
+            <a:pPr indent="0" marL="0">
+              <a:buNone/>
+            </a:pPr>
+            <a:r>
+              <a:rPr lang="en-US" sz="1300" b="1" dirty="0">
                 <a:solidFill>
                   <a:srgbClr val="22252E"/>
                 </a:solidFill>
@@ -3963,38 +4078,38 @@
                 <a:ea typeface="Calibri" pitchFamily="34" charset="-122"/>
                 <a:cs typeface="Calibri" pitchFamily="34" charset="-120"/>
               </a:rPr>
-              <a:t>An intruder who sits quietly builds what one author calls a portfolio of future options: escalate, disrupt, keep watching, or withdraw. Over time they accumulate real power on that network without ever using it.</a:t>
-            </a:r>
-            <a:endParaRPr lang="en-US" sz="1350" dirty="0"/>
-          </a:p>
-        </p:txBody>
-      </p:sp>
-      <p:sp>
-        <p:nvSpPr>
-          <p:cNvPr id="19" name="Text 17"/>
-          <p:cNvSpPr/>
-          <p:nvPr/>
-        </p:nvSpPr>
-        <p:spPr>
-          <a:xfrm>
-            <a:off x="640080" y="6327648"/>
-            <a:ext cx="10881360" cy="274320"/>
-          </a:xfrm>
-          <a:prstGeom prst="rect">
-            <a:avLst/>
-          </a:prstGeom>
-          <a:noFill/>
-          <a:ln/>
-        </p:spPr>
-        <p:txBody>
-          <a:bodyPr wrap="square" lIns="0" tIns="0" rIns="0" bIns="0" rtlCol="0" anchor="ctr"/>
-          <a:lstStyle/>
-          <a:p>
-            <a:pPr indent="0" marL="0">
-              <a:buNone/>
-            </a:pPr>
-            <a:r>
-              <a:rPr lang="en-US" sz="1050" dirty="0">
+              <a:t>General Paul Nakasone</a:t>
+            </a:r>
+            <a:endParaRPr lang="en-US" sz="1300" dirty="0"/>
+          </a:p>
+        </p:txBody>
+      </p:sp>
+      <p:sp>
+        <p:nvSpPr>
+          <p:cNvPr id="13" name="Text 11"/>
+          <p:cNvSpPr/>
+          <p:nvPr/>
+        </p:nvSpPr>
+        <p:spPr>
+          <a:xfrm>
+            <a:off x="7360920" y="4197096"/>
+            <a:ext cx="3886200" cy="256032"/>
+          </a:xfrm>
+          <a:prstGeom prst="rect">
+            <a:avLst/>
+          </a:prstGeom>
+          <a:noFill/>
+          <a:ln/>
+        </p:spPr>
+        <p:txBody>
+          <a:bodyPr wrap="square" lIns="0" tIns="0" rIns="0" bIns="0" rtlCol="0" anchor="ctr"/>
+          <a:lstStyle/>
+          <a:p>
+            <a:pPr indent="0" marL="0">
+              <a:buNone/>
+            </a:pPr>
+            <a:r>
+              <a:rPr lang="en-US" sz="1200" dirty="0">
                 <a:solidFill>
                   <a:srgbClr val="6A6F7D"/>
                 </a:solidFill>
@@ -4002,7 +4117,88 @@
                 <a:ea typeface="Calibri" pitchFamily="34" charset="-122"/>
                 <a:cs typeface="Calibri" pitchFamily="34" charset="-120"/>
               </a:rPr>
-              <a:t>Dwell time and detection figures from Kabir et al. (2026); the portfolio of options from Guttieri (2025).</a:t>
+              <a:t>Then head of US Cyber Command</a:t>
+            </a:r>
+            <a:endParaRPr lang="en-US" sz="1200" dirty="0"/>
+          </a:p>
+        </p:txBody>
+      </p:sp>
+      <p:sp>
+        <p:nvSpPr>
+          <p:cNvPr id="14" name="Text 12"/>
+          <p:cNvSpPr/>
+          <p:nvPr/>
+        </p:nvSpPr>
+        <p:spPr>
+          <a:xfrm>
+            <a:off x="640080" y="5532120"/>
+            <a:ext cx="10881360" cy="502920"/>
+          </a:xfrm>
+          <a:prstGeom prst="rect">
+            <a:avLst/>
+          </a:prstGeom>
+          <a:noFill/>
+          <a:ln/>
+        </p:spPr>
+        <p:txBody>
+          <a:bodyPr wrap="square" lIns="0" tIns="0" rIns="0" bIns="0" rtlCol="0" anchor="ctr"/>
+          <a:lstStyle/>
+          <a:p>
+            <a:pPr indent="0" marL="0">
+              <a:lnSpc>
+                <a:spcPts val="2000"/>
+              </a:lnSpc>
+              <a:buNone/>
+            </a:pPr>
+            <a:r>
+              <a:rPr lang="en-US" sz="1400" b="1" dirty="0">
+                <a:solidFill>
+                  <a:srgbClr val="1E2761"/>
+                </a:solidFill>
+                <a:latin typeface="Calibri" pitchFamily="34" charset="0"/>
+                <a:ea typeface="Calibri" pitchFamily="34" charset="-122"/>
+                <a:cs typeface="Calibri" pitchFamily="34" charset="-120"/>
+              </a:rPr>
+              <a:t>Guam is the logistics hub for any Pacific crisis. A target tied to one specific scenario says more about intent than a target chosen at random.</a:t>
+            </a:r>
+            <a:endParaRPr lang="en-US" sz="1400" dirty="0"/>
+          </a:p>
+        </p:txBody>
+      </p:sp>
+      <p:sp>
+        <p:nvSpPr>
+          <p:cNvPr id="15" name="Text 13"/>
+          <p:cNvSpPr/>
+          <p:nvPr/>
+        </p:nvSpPr>
+        <p:spPr>
+          <a:xfrm>
+            <a:off x="640080" y="6355080"/>
+            <a:ext cx="10881360" cy="274320"/>
+          </a:xfrm>
+          <a:prstGeom prst="rect">
+            <a:avLst/>
+          </a:prstGeom>
+          <a:noFill/>
+          <a:ln/>
+        </p:spPr>
+        <p:txBody>
+          <a:bodyPr wrap="square" lIns="0" tIns="0" rIns="0" bIns="0" rtlCol="0" anchor="ctr"/>
+          <a:lstStyle/>
+          <a:p>
+            <a:pPr indent="0" marL="0">
+              <a:buNone/>
+            </a:pPr>
+            <a:r>
+              <a:rPr lang="en-US" sz="1050" dirty="0">
+                <a:solidFill>
+                  <a:srgbClr val="6A6F7D"/>
+                </a:solidFill>
+                <a:latin typeface="Calibri" pitchFamily="34" charset="0"/>
+                <a:ea typeface="Calibri" pitchFamily="34" charset="-122"/>
+                <a:cs typeface="Calibri" pitchFamily="34" charset="-120"/>
+              </a:rPr>
+              <a:t>Guttieri (2025); Codreanu (2025); Dimitrov and Andreev (2025).</a:t>
             </a:r>
             <a:endParaRPr lang="en-US" sz="1050" dirty="0"/>
           </a:p>
@@ -4073,7 +4269,7 @@
                 <a:ea typeface="Calibri" pitchFamily="34" charset="-122"/>
                 <a:cs typeface="Calibri" pitchFamily="34" charset="-120"/>
               </a:rPr>
-              <a:t>THE STANDARD READING</a:t>
+              <a:t>THE ASSUMPTION</a:t>
             </a:r>
             <a:endParaRPr lang="en-US" sz="1200" dirty="0"/>
           </a:p>
@@ -4112,7 +4308,7 @@
                 <a:ea typeface="Cambria" pitchFamily="34" charset="-122"/>
                 <a:cs typeface="Cambria" pitchFamily="34" charset="-120"/>
               </a:rPr>
-              <a:t>So analysts read it as a warning</a:t>
+              <a:t>Why the field reads this as a warning</a:t>
             </a:r>
             <a:endParaRPr lang="en-US" sz="3000" dirty="0"/>
           </a:p>
@@ -4126,7 +4322,7 @@
         </p:nvSpPr>
         <p:spPr>
           <a:xfrm>
-            <a:off x="640080" y="1298448"/>
+            <a:off x="640080" y="1261872"/>
             <a:ext cx="10881360" cy="777240"/>
           </a:xfrm>
           <a:prstGeom prst="rect">
@@ -4168,7 +4364,7 @@
         </p:nvSpPr>
         <p:spPr>
           <a:xfrm>
-            <a:off x="640080" y="2212848"/>
+            <a:off x="640080" y="2176272"/>
             <a:ext cx="3429000" cy="2286000"/>
           </a:xfrm>
           <a:prstGeom prst="roundRect">
@@ -4195,7 +4391,7 @@
         </p:nvSpPr>
         <p:spPr>
           <a:xfrm>
-            <a:off x="896112" y="2468880"/>
+            <a:off x="896112" y="2432304"/>
             <a:ext cx="502920" cy="502920"/>
           </a:xfrm>
           <a:prstGeom prst="ellipse">
@@ -4215,7 +4411,7 @@
         </p:nvSpPr>
         <p:spPr>
           <a:xfrm>
-            <a:off x="896112" y="2468880"/>
+            <a:off x="896112" y="2432304"/>
             <a:ext cx="502920" cy="502920"/>
           </a:xfrm>
           <a:prstGeom prst="rect">
@@ -4254,7 +4450,7 @@
         </p:nvSpPr>
         <p:spPr>
           <a:xfrm>
-            <a:off x="896112" y="3127248"/>
+            <a:off x="896112" y="3090672"/>
             <a:ext cx="2926080" cy="365760"/>
           </a:xfrm>
           <a:prstGeom prst="rect">
@@ -4293,7 +4489,7 @@
         </p:nvSpPr>
         <p:spPr>
           <a:xfrm>
-            <a:off x="896112" y="3520440"/>
+            <a:off x="896112" y="3483864"/>
             <a:ext cx="2926080" cy="914400"/>
           </a:xfrm>
           <a:prstGeom prst="rect">
@@ -4335,7 +4531,7 @@
         </p:nvSpPr>
         <p:spPr>
           <a:xfrm>
-            <a:off x="4325112" y="2212848"/>
+            <a:off x="4325112" y="2176272"/>
             <a:ext cx="3429000" cy="2286000"/>
           </a:xfrm>
           <a:prstGeom prst="roundRect">
@@ -4362,7 +4558,7 @@
         </p:nvSpPr>
         <p:spPr>
           <a:xfrm>
-            <a:off x="4581144" y="2468880"/>
+            <a:off x="4581144" y="2432304"/>
             <a:ext cx="502920" cy="502920"/>
           </a:xfrm>
           <a:prstGeom prst="ellipse">
@@ -4382,7 +4578,7 @@
         </p:nvSpPr>
         <p:spPr>
           <a:xfrm>
-            <a:off x="4581144" y="2468880"/>
+            <a:off x="4581144" y="2432304"/>
             <a:ext cx="502920" cy="502920"/>
           </a:xfrm>
           <a:prstGeom prst="rect">
@@ -4421,7 +4617,7 @@
         </p:nvSpPr>
         <p:spPr>
           <a:xfrm>
-            <a:off x="4581144" y="3127248"/>
+            <a:off x="4581144" y="3090672"/>
             <a:ext cx="2926080" cy="365760"/>
           </a:xfrm>
           <a:prstGeom prst="rect">
@@ -4460,7 +4656,7 @@
         </p:nvSpPr>
         <p:spPr>
           <a:xfrm>
-            <a:off x="4581144" y="3520440"/>
+            <a:off x="4581144" y="3483864"/>
             <a:ext cx="2926080" cy="914400"/>
           </a:xfrm>
           <a:prstGeom prst="rect">
@@ -4502,7 +4698,7 @@
         </p:nvSpPr>
         <p:spPr>
           <a:xfrm>
-            <a:off x="8010144" y="2212848"/>
+            <a:off x="8010144" y="2176272"/>
             <a:ext cx="3429000" cy="2286000"/>
           </a:xfrm>
           <a:prstGeom prst="roundRect">
@@ -4529,7 +4725,7 @@
         </p:nvSpPr>
         <p:spPr>
           <a:xfrm>
-            <a:off x="8266176" y="2468880"/>
+            <a:off x="8266176" y="2432304"/>
             <a:ext cx="502920" cy="502920"/>
           </a:xfrm>
           <a:prstGeom prst="ellipse">
@@ -4549,7 +4745,7 @@
         </p:nvSpPr>
         <p:spPr>
           <a:xfrm>
-            <a:off x="8266176" y="2468880"/>
+            <a:off x="8266176" y="2432304"/>
             <a:ext cx="502920" cy="502920"/>
           </a:xfrm>
           <a:prstGeom prst="rect">
@@ -4588,7 +4784,7 @@
         </p:nvSpPr>
         <p:spPr>
           <a:xfrm>
-            <a:off x="8266176" y="3127248"/>
+            <a:off x="8266176" y="3090672"/>
             <a:ext cx="2926080" cy="365760"/>
           </a:xfrm>
           <a:prstGeom prst="rect">
@@ -4627,7 +4823,7 @@
         </p:nvSpPr>
         <p:spPr>
           <a:xfrm>
-            <a:off x="8266176" y="3520440"/>
+            <a:off x="8266176" y="3483864"/>
             <a:ext cx="2926080" cy="914400"/>
           </a:xfrm>
           <a:prstGeom prst="rect">
@@ -4669,12 +4865,12 @@
         </p:nvSpPr>
         <p:spPr>
           <a:xfrm>
-            <a:off x="640080" y="4754880"/>
-            <a:ext cx="10881360" cy="1005840"/>
+            <a:off x="640080" y="4709160"/>
+            <a:ext cx="10881360" cy="1051560"/>
           </a:xfrm>
           <a:prstGeom prst="roundRect">
             <a:avLst>
-              <a:gd name="adj" fmla="val 7273"/>
+              <a:gd name="adj" fmla="val 6957"/>
             </a:avLst>
           </a:prstGeom>
           <a:solidFill>
@@ -4696,8 +4892,8 @@
         </p:nvSpPr>
         <p:spPr>
           <a:xfrm>
-            <a:off x="1005840" y="4882896"/>
-            <a:ext cx="10149840" cy="777240"/>
+            <a:off x="1005840" y="4846320"/>
+            <a:ext cx="10149840" cy="822960"/>
           </a:xfrm>
           <a:prstGeom prst="rect">
             <a:avLst/>
@@ -4724,9 +4920,48 @@
                 <a:ea typeface="Cambria" pitchFamily="34" charset="-122"/>
                 <a:cs typeface="Cambria" pitchFamily="34" charset="-120"/>
               </a:rPr>
-              <a:t>This whole reading rests on one word: expensive. Take that away and the reasoning has nothing left to stand on.</a:t>
+              <a:t>The whole reading rests on one word: expensive. Take that away and the reasoning has nothing left to stand on. That is the assumption this study tests.</a:t>
             </a:r>
             <a:endParaRPr lang="en-US" sz="1700" dirty="0"/>
+          </a:p>
+        </p:txBody>
+      </p:sp>
+      <p:sp>
+        <p:nvSpPr>
+          <p:cNvPr id="22" name="Text 20"/>
+          <p:cNvSpPr/>
+          <p:nvPr/>
+        </p:nvSpPr>
+        <p:spPr>
+          <a:xfrm>
+            <a:off x="640080" y="6355080"/>
+            <a:ext cx="10881360" cy="274320"/>
+          </a:xfrm>
+          <a:prstGeom prst="rect">
+            <a:avLst/>
+          </a:prstGeom>
+          <a:noFill/>
+          <a:ln/>
+        </p:spPr>
+        <p:txBody>
+          <a:bodyPr wrap="square" lIns="0" tIns="0" rIns="0" bIns="0" rtlCol="0" anchor="ctr"/>
+          <a:lstStyle/>
+          <a:p>
+            <a:pPr indent="0" marL="0">
+              <a:buNone/>
+            </a:pPr>
+            <a:r>
+              <a:rPr lang="en-US" sz="1050" dirty="0">
+                <a:solidFill>
+                  <a:srgbClr val="6A6F7D"/>
+                </a:solidFill>
+                <a:latin typeface="Calibri" pitchFamily="34" charset="0"/>
+                <a:ea typeface="Calibri" pitchFamily="34" charset="-122"/>
+                <a:cs typeface="Calibri" pitchFamily="34" charset="-120"/>
+              </a:rPr>
+              <a:t>The reading and the quoted rule are from Guttieri (2025).</a:t>
+            </a:r>
+            <a:endParaRPr lang="en-US" sz="1050" dirty="0"/>
           </a:p>
         </p:txBody>
       </p:sp>
@@ -4795,7 +5030,7 @@
                 <a:ea typeface="Calibri" pitchFamily="34" charset="-122"/>
                 <a:cs typeface="Calibri" pitchFamily="34" charset="-120"/>
               </a:rPr>
-              <a:t>THE CENTRAL FINDING</a:t>
+              <a:t>FINDING ONE</a:t>
             </a:r>
             <a:endParaRPr lang="en-US" sz="1200" dirty="0"/>
           </a:p>
@@ -4834,7 +5069,7 @@
                 <a:ea typeface="Cambria" pitchFamily="34" charset="-122"/>
                 <a:cs typeface="Cambria" pitchFamily="34" charset="-120"/>
               </a:rPr>
-              <a:t>But governments do not act as if they believe it</a:t>
+              <a:t>Governments do not act as if they believe it</a:t>
             </a:r>
             <a:endParaRPr lang="en-US" sz="3000" dirty="0"/>
           </a:p>
@@ -4848,12 +5083,12 @@
         </p:nvSpPr>
         <p:spPr>
           <a:xfrm>
-            <a:off x="640080" y="1298448"/>
-            <a:ext cx="5349240" cy="3429000"/>
+            <a:off x="640080" y="1280160"/>
+            <a:ext cx="5349240" cy="3474720"/>
           </a:xfrm>
           <a:prstGeom prst="roundRect">
             <a:avLst>
-              <a:gd name="adj" fmla="val 2133"/>
+              <a:gd name="adj" fmla="val 2105"/>
             </a:avLst>
           </a:prstGeom>
           <a:solidFill>
@@ -4875,7 +5110,7 @@
         </p:nvSpPr>
         <p:spPr>
           <a:xfrm>
-            <a:off x="960120" y="1517904"/>
+            <a:off x="960120" y="1499616"/>
             <a:ext cx="4663440" cy="411480"/>
           </a:xfrm>
           <a:prstGeom prst="rect">
@@ -4914,7 +5149,7 @@
         </p:nvSpPr>
         <p:spPr>
           <a:xfrm>
-            <a:off x="960120" y="1947672"/>
+            <a:off x="960120" y="1938528"/>
             <a:ext cx="4663440" cy="594360"/>
           </a:xfrm>
           <a:prstGeom prst="rect">
@@ -5102,7 +5337,7 @@
                 <a:ea typeface="Calibri" pitchFamily="34" charset="-122"/>
                 <a:cs typeface="Calibri" pitchFamily="34" charset="-120"/>
               </a:rPr>
-              <a:t>Guidance written for network engineers.</a:t>
+              <a:t>Guidance written for engineers.</a:t>
             </a:r>
             <a:endParaRPr lang="en-US" sz="1350" dirty="0"/>
           </a:p>
@@ -5116,12 +5351,12 @@
         </p:nvSpPr>
         <p:spPr>
           <a:xfrm>
-            <a:off x="6263640" y="1298448"/>
-            <a:ext cx="5349240" cy="3429000"/>
+            <a:off x="6263640" y="1280160"/>
+            <a:ext cx="5349240" cy="3474720"/>
           </a:xfrm>
           <a:prstGeom prst="roundRect">
             <a:avLst>
-              <a:gd name="adj" fmla="val 2133"/>
+              <a:gd name="adj" fmla="val 2105"/>
             </a:avLst>
           </a:prstGeom>
           <a:solidFill>
@@ -5143,7 +5378,7 @@
         </p:nvSpPr>
         <p:spPr>
           <a:xfrm>
-            <a:off x="6583680" y="1517904"/>
+            <a:off x="6583680" y="1499616"/>
             <a:ext cx="4663440" cy="411480"/>
           </a:xfrm>
           <a:prstGeom prst="rect">
@@ -5182,7 +5417,7 @@
         </p:nvSpPr>
         <p:spPr>
           <a:xfrm>
-            <a:off x="6583680" y="1947672"/>
+            <a:off x="6583680" y="1938528"/>
             <a:ext cx="4663440" cy="594360"/>
           </a:xfrm>
           <a:prstGeom prst="rect">
@@ -5384,7 +5619,7 @@
         </p:nvSpPr>
         <p:spPr>
           <a:xfrm>
-            <a:off x="640080" y="4882896"/>
+            <a:off x="640080" y="4956048"/>
             <a:ext cx="10881360" cy="658368"/>
           </a:xfrm>
           <a:prstGeom prst="rect">
@@ -5426,23 +5661,20 @@
         </p:nvSpPr>
         <p:spPr>
           <a:xfrm>
-            <a:off x="640080" y="5541264"/>
-            <a:ext cx="10881360" cy="566928"/>
-          </a:xfrm>
-          <a:prstGeom prst="rect">
-            <a:avLst/>
-          </a:prstGeom>
-          <a:noFill/>
-          <a:ln/>
-        </p:spPr>
-        <p:txBody>
-          <a:bodyPr wrap="square" lIns="0" tIns="0" rIns="0" bIns="0" rtlCol="0" anchor="ctr"/>
-          <a:lstStyle/>
-          <a:p>
-            <a:pPr indent="0" marL="0">
-              <a:lnSpc>
-                <a:spcPts val="2000"/>
-              </a:lnSpc>
+            <a:off x="640080" y="5596128"/>
+            <a:ext cx="10881360" cy="548640"/>
+          </a:xfrm>
+          <a:prstGeom prst="rect">
+            <a:avLst/>
+          </a:prstGeom>
+          <a:noFill/>
+          <a:ln/>
+        </p:spPr>
+        <p:txBody>
+          <a:bodyPr wrap="square" lIns="0" tIns="0" rIns="0" bIns="0" rtlCol="0" anchor="ctr"/>
+          <a:lstStyle/>
+          <a:p>
+            <a:pPr indent="0" marL="0">
               <a:buNone/>
             </a:pPr>
             <a:r>
@@ -5454,7 +5686,7 @@
                 <a:ea typeface="Calibri" pitchFamily="34" charset="-122"/>
                 <a:cs typeface="Calibri" pitchFamily="34" charset="-120"/>
               </a:rPr>
-              <a:t>Governments appear to respond to what is easy to explain and what fits past practice, not to what is actually dangerous.</a:t>
+              <a:t>Governments respond to what is easy to explain and what fits past practice, not to what is actually dangerous.</a:t>
             </a:r>
             <a:endParaRPr lang="en-US" sz="1450" dirty="0"/>
           </a:p>
@@ -5468,7 +5700,7 @@
         </p:nvSpPr>
         <p:spPr>
           <a:xfrm>
-            <a:off x="640080" y="6327648"/>
+            <a:off x="640080" y="6355080"/>
             <a:ext cx="10881360" cy="274320"/>
           </a:xfrm>
           <a:prstGeom prst="rect">
@@ -5493,7 +5725,7 @@
                 <a:ea typeface="Calibri" pitchFamily="34" charset="-122"/>
                 <a:cs typeface="Calibri" pitchFamily="34" charset="-120"/>
               </a:rPr>
-              <a:t>Volt Typhoon response coded in Baram (2026) from twenty joint attribution cases; Salt Typhoon sanctions recorded in Urbanczyk et al. (2025).</a:t>
+              <a:t>Volt Typhoon response coded in Baram (2026); Salt Typhoon sanctions in Urbanczyk et al. (2025).</a:t>
             </a:r>
             <a:endParaRPr lang="en-US" sz="1050" dirty="0"/>
           </a:p>
@@ -5564,7 +5796,7 @@
                 <a:ea typeface="Calibri" pitchFamily="34" charset="-122"/>
                 <a:cs typeface="Calibri" pitchFamily="34" charset="-120"/>
               </a:rPr>
-              <a:t>WHY THE MESSAGE FAILS</a:t>
+              <a:t>WHY</a:t>
             </a:r>
             <a:endParaRPr lang="en-US" sz="1200" dirty="0"/>
           </a:p>
@@ -5617,7 +5849,7 @@
         </p:nvSpPr>
         <p:spPr>
           <a:xfrm>
-            <a:off x="640080" y="1362456"/>
+            <a:off x="640080" y="1335024"/>
             <a:ext cx="530352" cy="530352"/>
           </a:xfrm>
           <a:prstGeom prst="ellipse">
@@ -5637,7 +5869,7 @@
         </p:nvSpPr>
         <p:spPr>
           <a:xfrm>
-            <a:off x="640080" y="1362456"/>
+            <a:off x="640080" y="1335024"/>
             <a:ext cx="530352" cy="530352"/>
           </a:xfrm>
           <a:prstGeom prst="rect">
@@ -5676,7 +5908,7 @@
         </p:nvSpPr>
         <p:spPr>
           <a:xfrm>
-            <a:off x="1463040" y="1325880"/>
+            <a:off x="1463040" y="1298448"/>
             <a:ext cx="3566160" cy="347472"/>
           </a:xfrm>
           <a:prstGeom prst="rect">
@@ -5715,7 +5947,7 @@
         </p:nvSpPr>
         <p:spPr>
           <a:xfrm>
-            <a:off x="5120640" y="1325880"/>
+            <a:off x="5120640" y="1298448"/>
             <a:ext cx="6400800" cy="914400"/>
           </a:xfrm>
           <a:prstGeom prst="rect">
@@ -5757,7 +5989,7 @@
         </p:nvSpPr>
         <p:spPr>
           <a:xfrm>
-            <a:off x="640080" y="2660904"/>
+            <a:off x="640080" y="2633472"/>
             <a:ext cx="530352" cy="530352"/>
           </a:xfrm>
           <a:prstGeom prst="ellipse">
@@ -5777,7 +6009,7 @@
         </p:nvSpPr>
         <p:spPr>
           <a:xfrm>
-            <a:off x="640080" y="2660904"/>
+            <a:off x="640080" y="2633472"/>
             <a:ext cx="530352" cy="530352"/>
           </a:xfrm>
           <a:prstGeom prst="rect">
@@ -5816,7 +6048,7 @@
         </p:nvSpPr>
         <p:spPr>
           <a:xfrm>
-            <a:off x="1463040" y="2624328"/>
+            <a:off x="1463040" y="2596896"/>
             <a:ext cx="3566160" cy="347472"/>
           </a:xfrm>
           <a:prstGeom prst="rect">
@@ -5855,7 +6087,7 @@
         </p:nvSpPr>
         <p:spPr>
           <a:xfrm>
-            <a:off x="5120640" y="2624328"/>
+            <a:off x="5120640" y="2596896"/>
             <a:ext cx="6400800" cy="914400"/>
           </a:xfrm>
           <a:prstGeom prst="rect">
@@ -5897,7 +6129,7 @@
         </p:nvSpPr>
         <p:spPr>
           <a:xfrm>
-            <a:off x="640080" y="3959352"/>
+            <a:off x="640080" y="3931920"/>
             <a:ext cx="530352" cy="530352"/>
           </a:xfrm>
           <a:prstGeom prst="ellipse">
@@ -5917,7 +6149,7 @@
         </p:nvSpPr>
         <p:spPr>
           <a:xfrm>
-            <a:off x="640080" y="3959352"/>
+            <a:off x="640080" y="3931920"/>
             <a:ext cx="530352" cy="530352"/>
           </a:xfrm>
           <a:prstGeom prst="rect">
@@ -5956,7 +6188,7 @@
         </p:nvSpPr>
         <p:spPr>
           <a:xfrm>
-            <a:off x="1463040" y="3922776"/>
+            <a:off x="1463040" y="3895344"/>
             <a:ext cx="3566160" cy="347472"/>
           </a:xfrm>
           <a:prstGeom prst="rect">
@@ -5995,7 +6227,7 @@
         </p:nvSpPr>
         <p:spPr>
           <a:xfrm>
-            <a:off x="5120640" y="3922776"/>
+            <a:off x="5120640" y="3895344"/>
             <a:ext cx="6400800" cy="914400"/>
           </a:xfrm>
           <a:prstGeom prst="rect">
@@ -6037,7 +6269,7 @@
         </p:nvSpPr>
         <p:spPr>
           <a:xfrm>
-            <a:off x="640080" y="5321808"/>
+            <a:off x="640080" y="5303520"/>
             <a:ext cx="10881360" cy="914400"/>
           </a:xfrm>
           <a:prstGeom prst="roundRect">
@@ -6064,7 +6296,7 @@
         </p:nvSpPr>
         <p:spPr>
           <a:xfrm>
-            <a:off x="1005840" y="5431536"/>
+            <a:off x="1005840" y="5413248"/>
             <a:ext cx="10149840" cy="713232"/>
           </a:xfrm>
           <a:prstGeom prst="rect">
@@ -6103,7 +6335,7 @@
         </p:nvSpPr>
         <p:spPr>
           <a:xfrm>
-            <a:off x="640080" y="6327648"/>
+            <a:off x="640080" y="6355080"/>
             <a:ext cx="10881360" cy="274320"/>
           </a:xfrm>
           <a:prstGeom prst="rect">
@@ -6128,7 +6360,7 @@
                 <a:ea typeface="Calibri" pitchFamily="34" charset="-122"/>
                 <a:cs typeface="Calibri" pitchFamily="34" charset="-120"/>
               </a:rPr>
-              <a:t>Salience from Sullivan (2025); denial from Singh, Jash and Nanjappa (2025) and Codreanu (2025); audience from Baram (2026).</a:t>
+              <a:t>Sullivan (2025); Singh, Jash and Nanjappa (2025); Codreanu (2025); Baram (2026).</a:t>
             </a:r>
             <a:endParaRPr lang="en-US" sz="1050" dirty="0"/>
           </a:p>
@@ -6199,7 +6431,7 @@
                 <a:ea typeface="Calibri" pitchFamily="34" charset="-122"/>
                 <a:cs typeface="Calibri" pitchFamily="34" charset="-120"/>
               </a:rPr>
-              <a:t>THE RECORD</a:t>
+              <a:t>FINDING TWO</a:t>
             </a:r>
             <a:endParaRPr lang="en-US" sz="1200" dirty="0"/>
           </a:p>
@@ -6252,12 +6484,12 @@
         </p:nvSpPr>
         <p:spPr>
           <a:xfrm>
-            <a:off x="640080" y="1298448"/>
-            <a:ext cx="7223760" cy="1051560"/>
+            <a:off x="640080" y="1280160"/>
+            <a:ext cx="7223760" cy="1060704"/>
           </a:xfrm>
           <a:prstGeom prst="roundRect">
             <a:avLst>
-              <a:gd name="adj" fmla="val 6957"/>
+              <a:gd name="adj" fmla="val 6897"/>
             </a:avLst>
           </a:prstGeom>
           <a:solidFill>
@@ -6279,7 +6511,7 @@
         </p:nvSpPr>
         <p:spPr>
           <a:xfrm>
-            <a:off x="914400" y="1426464"/>
+            <a:off x="914400" y="1408176"/>
             <a:ext cx="4023360" cy="310896"/>
           </a:xfrm>
           <a:prstGeom prst="rect">
@@ -6318,7 +6550,7 @@
         </p:nvSpPr>
         <p:spPr>
           <a:xfrm>
-            <a:off x="914400" y="1755648"/>
+            <a:off x="914400" y="1737360"/>
             <a:ext cx="4023360" cy="274320"/>
           </a:xfrm>
           <a:prstGeom prst="rect">
@@ -6357,8 +6589,8 @@
         </p:nvSpPr>
         <p:spPr>
           <a:xfrm>
-            <a:off x="5074920" y="1426464"/>
-            <a:ext cx="2651760" cy="841248"/>
+            <a:off x="5074920" y="1408176"/>
+            <a:ext cx="2651760" cy="859536"/>
           </a:xfrm>
           <a:prstGeom prst="rect">
             <a:avLst/>
@@ -6400,11 +6632,11 @@
         <p:spPr>
           <a:xfrm>
             <a:off x="640080" y="2468880"/>
-            <a:ext cx="7223760" cy="1051560"/>
+            <a:ext cx="7223760" cy="1060704"/>
           </a:xfrm>
           <a:prstGeom prst="roundRect">
             <a:avLst>
-              <a:gd name="adj" fmla="val 6957"/>
+              <a:gd name="adj" fmla="val 6897"/>
             </a:avLst>
           </a:prstGeom>
           <a:solidFill>
@@ -6505,7 +6737,7 @@
         <p:spPr>
           <a:xfrm>
             <a:off x="5074920" y="2596896"/>
-            <a:ext cx="2651760" cy="841248"/>
+            <a:ext cx="2651760" cy="859536"/>
           </a:xfrm>
           <a:prstGeom prst="rect">
             <a:avLst/>
@@ -6546,12 +6778,12 @@
         </p:nvSpPr>
         <p:spPr>
           <a:xfrm>
-            <a:off x="640080" y="3639312"/>
-            <a:ext cx="7223760" cy="1051560"/>
+            <a:off x="640080" y="3657600"/>
+            <a:ext cx="7223760" cy="1060704"/>
           </a:xfrm>
           <a:prstGeom prst="roundRect">
             <a:avLst>
-              <a:gd name="adj" fmla="val 6957"/>
+              <a:gd name="adj" fmla="val 6897"/>
             </a:avLst>
           </a:prstGeom>
           <a:solidFill>
@@ -6573,7 +6805,7 @@
         </p:nvSpPr>
         <p:spPr>
           <a:xfrm>
-            <a:off x="914400" y="3767328"/>
+            <a:off x="914400" y="3785616"/>
             <a:ext cx="4023360" cy="310896"/>
           </a:xfrm>
           <a:prstGeom prst="rect">
@@ -6612,7 +6844,7 @@
         </p:nvSpPr>
         <p:spPr>
           <a:xfrm>
-            <a:off x="914400" y="4096512"/>
+            <a:off x="914400" y="4114800"/>
             <a:ext cx="4023360" cy="274320"/>
           </a:xfrm>
           <a:prstGeom prst="rect">
@@ -6651,8 +6883,8 @@
         </p:nvSpPr>
         <p:spPr>
           <a:xfrm>
-            <a:off x="5074920" y="3767328"/>
-            <a:ext cx="2651760" cy="841248"/>
+            <a:off x="5074920" y="3785616"/>
+            <a:ext cx="2651760" cy="859536"/>
           </a:xfrm>
           <a:prstGeom prst="rect">
             <a:avLst/>
@@ -6693,8 +6925,8 @@
         </p:nvSpPr>
         <p:spPr>
           <a:xfrm>
-            <a:off x="8183880" y="1298448"/>
-            <a:ext cx="3337560" cy="3520440"/>
+            <a:off x="8183880" y="1280160"/>
+            <a:ext cx="3337560" cy="3566160"/>
           </a:xfrm>
           <a:prstGeom prst="roundRect">
             <a:avLst>
@@ -6720,7 +6952,7 @@
         </p:nvSpPr>
         <p:spPr>
           <a:xfrm>
-            <a:off x="8366760" y="1572768"/>
+            <a:off x="8366760" y="1554480"/>
             <a:ext cx="2971800" cy="1417320"/>
           </a:xfrm>
           <a:prstGeom prst="rect">
@@ -6759,7 +6991,7 @@
         </p:nvSpPr>
         <p:spPr>
           <a:xfrm>
-            <a:off x="8366760" y="3035808"/>
+            <a:off x="8366760" y="3017520"/>
             <a:ext cx="2971800" cy="640080"/>
           </a:xfrm>
           <a:prstGeom prst="rect">
@@ -6849,7 +7081,7 @@
                 <a:ea typeface="Calibri" pitchFamily="34" charset="-122"/>
                 <a:cs typeface="Calibri" pitchFamily="34" charset="-120"/>
               </a:rPr>
-              <a:t>Three chances to observe</a:t>
+              <a:t>Three chances to see what</a:t>
             </a:r>
             <a:endParaRPr lang="en-US" sz="1250" dirty="0"/>
           </a:p>
@@ -6869,7 +7101,7 @@
                 <a:ea typeface="Calibri" pitchFamily="34" charset="-122"/>
                 <a:cs typeface="Calibri" pitchFamily="34" charset="-120"/>
               </a:rPr>
-              <a:t>what it means. Not one</a:t>
+              <a:t>it means. Not one</a:t>
             </a:r>
             <a:endParaRPr lang="en-US" sz="1250" dirty="0"/>
           </a:p>
@@ -6903,8 +7135,8 @@
         </p:nvSpPr>
         <p:spPr>
           <a:xfrm>
-            <a:off x="640080" y="4983480"/>
-            <a:ext cx="10881360" cy="384048"/>
+            <a:off x="640080" y="5010912"/>
+            <a:ext cx="10881360" cy="411480"/>
           </a:xfrm>
           <a:prstGeom prst="rect">
             <a:avLst/>
@@ -6942,8 +7174,8 @@
         </p:nvSpPr>
         <p:spPr>
           <a:xfrm>
-            <a:off x="640080" y="5394960"/>
-            <a:ext cx="10881360" cy="384048"/>
+            <a:off x="640080" y="5431536"/>
+            <a:ext cx="10881360" cy="411480"/>
           </a:xfrm>
           <a:prstGeom prst="rect">
             <a:avLst/>
@@ -6981,7 +7213,7 @@
         </p:nvSpPr>
         <p:spPr>
           <a:xfrm>
-            <a:off x="640080" y="6327648"/>
+            <a:off x="640080" y="6355080"/>
             <a:ext cx="10881360" cy="274320"/>
           </a:xfrm>
           <a:prstGeom prst="rect">
@@ -7077,7 +7309,7 @@
                 <a:ea typeface="Calibri" pitchFamily="34" charset="-122"/>
                 <a:cs typeface="Calibri" pitchFamily="34" charset="-120"/>
               </a:rPr>
-              <a:t>THE TECHNOLOGY</a:t>
+              <a:t>FINDING THREE</a:t>
             </a:r>
             <a:endParaRPr lang="en-US" sz="1200" dirty="0"/>
           </a:p>
@@ -7130,7 +7362,7 @@
         </p:nvSpPr>
         <p:spPr>
           <a:xfrm>
-            <a:off x="640080" y="1335024"/>
+            <a:off x="640080" y="1316736"/>
             <a:ext cx="502920" cy="502920"/>
           </a:xfrm>
           <a:prstGeom prst="ellipse">
@@ -7150,7 +7382,7 @@
         </p:nvSpPr>
         <p:spPr>
           <a:xfrm>
-            <a:off x="640080" y="1335024"/>
+            <a:off x="640080" y="1316736"/>
             <a:ext cx="502920" cy="502920"/>
           </a:xfrm>
           <a:prstGeom prst="rect">
@@ -7189,7 +7421,7 @@
         </p:nvSpPr>
         <p:spPr>
           <a:xfrm>
-            <a:off x="1417320" y="1298448"/>
+            <a:off x="1417320" y="1280160"/>
             <a:ext cx="10104120" cy="329184"/>
           </a:xfrm>
           <a:prstGeom prst="rect">
@@ -7228,7 +7460,7 @@
         </p:nvSpPr>
         <p:spPr>
           <a:xfrm>
-            <a:off x="1417320" y="1645920"/>
+            <a:off x="1417320" y="1627632"/>
             <a:ext cx="10104120" cy="822960"/>
           </a:xfrm>
           <a:prstGeom prst="rect">
@@ -7270,7 +7502,7 @@
         </p:nvSpPr>
         <p:spPr>
           <a:xfrm>
-            <a:off x="640080" y="2615184"/>
+            <a:off x="640080" y="2596896"/>
             <a:ext cx="502920" cy="502920"/>
           </a:xfrm>
           <a:prstGeom prst="ellipse">
@@ -7290,7 +7522,7 @@
         </p:nvSpPr>
         <p:spPr>
           <a:xfrm>
-            <a:off x="640080" y="2615184"/>
+            <a:off x="640080" y="2596896"/>
             <a:ext cx="502920" cy="502920"/>
           </a:xfrm>
           <a:prstGeom prst="rect">
@@ -7329,7 +7561,7 @@
         </p:nvSpPr>
         <p:spPr>
           <a:xfrm>
-            <a:off x="1417320" y="2578608"/>
+            <a:off x="1417320" y="2560320"/>
             <a:ext cx="10104120" cy="329184"/>
           </a:xfrm>
           <a:prstGeom prst="rect">
@@ -7368,7 +7600,7 @@
         </p:nvSpPr>
         <p:spPr>
           <a:xfrm>
-            <a:off x="1417320" y="2926080"/>
+            <a:off x="1417320" y="2907792"/>
             <a:ext cx="10104120" cy="822960"/>
           </a:xfrm>
           <a:prstGeom prst="rect">
@@ -7410,7 +7642,7 @@
         </p:nvSpPr>
         <p:spPr>
           <a:xfrm>
-            <a:off x="640080" y="3895344"/>
+            <a:off x="640080" y="3877056"/>
             <a:ext cx="502920" cy="502920"/>
           </a:xfrm>
           <a:prstGeom prst="ellipse">
@@ -7430,7 +7662,7 @@
         </p:nvSpPr>
         <p:spPr>
           <a:xfrm>
-            <a:off x="640080" y="3895344"/>
+            <a:off x="640080" y="3877056"/>
             <a:ext cx="502920" cy="502920"/>
           </a:xfrm>
           <a:prstGeom prst="rect">
@@ -7469,7 +7701,7 @@
         </p:nvSpPr>
         <p:spPr>
           <a:xfrm>
-            <a:off x="1417320" y="3858768"/>
+            <a:off x="1417320" y="3840480"/>
             <a:ext cx="10104120" cy="329184"/>
           </a:xfrm>
           <a:prstGeom prst="rect">
@@ -7494,7 +7726,7 @@
                 <a:ea typeface="Cambria" pitchFamily="34" charset="-122"/>
                 <a:cs typeface="Cambria" pitchFamily="34" charset="-120"/>
               </a:rPr>
-              <a:t>Defenders currently cannot see, and that is the gap AI closes</a:t>
+              <a:t>Defenders cannot see, and that is the gap AI closes</a:t>
             </a:r>
             <a:endParaRPr lang="en-US" sz="1700" dirty="0"/>
           </a:p>
@@ -7508,7 +7740,7 @@
         </p:nvSpPr>
         <p:spPr>
           <a:xfrm>
-            <a:off x="1417320" y="4206240"/>
+            <a:off x="1417320" y="4187952"/>
             <a:ext cx="10104120" cy="822960"/>
           </a:xfrm>
           <a:prstGeom prst="rect">
@@ -7536,7 +7768,7 @@
                 <a:ea typeface="Calibri" pitchFamily="34" charset="-122"/>
                 <a:cs typeface="Calibri" pitchFamily="34" charset="-120"/>
               </a:rPr>
-              <a:t>Remember the numbers: 197 days to notice, and three quarters of intrusions found by outsiders. Intruders survive partly because detection is poor. Better automatic detection makes hiding harder, not easier.</a:t>
+              <a:t>Intrusions go unnoticed for 197 days on average, and roughly three quarters are found by outsiders rather than the victim. Intruders survive partly because detection is poor. Better detection makes hiding harder, not easier.</a:t>
             </a:r>
             <a:endParaRPr lang="en-US" sz="1350" dirty="0"/>
           </a:p>
@@ -7550,7 +7782,7 @@
         </p:nvSpPr>
         <p:spPr>
           <a:xfrm>
-            <a:off x="640080" y="5230368"/>
+            <a:off x="640080" y="5212080"/>
             <a:ext cx="10881360" cy="1005840"/>
           </a:xfrm>
           <a:prstGeom prst="roundRect">
@@ -7577,7 +7809,7 @@
         </p:nvSpPr>
         <p:spPr>
           <a:xfrm>
-            <a:off x="1005840" y="5340096"/>
+            <a:off x="1005840" y="5321808"/>
             <a:ext cx="10149840" cy="804672"/>
           </a:xfrm>
           <a:prstGeom prst="rect">
@@ -7639,7 +7871,7 @@
                 <a:ea typeface="Calibri" pitchFamily="34" charset="-122"/>
                 <a:cs typeface="Calibri" pitchFamily="34" charset="-120"/>
               </a:rPr>
-              <a:t>. But Ukraine was backed by Western agencies and by Microsoft, Google and Cisco. A poorer defender would give a different answer, so the real question is not whether AI helps attackers. It is which side can absorb it better.</a:t>
+              <a:t>. But Ukraine was backed by Western agencies and by Microsoft, Google and Cisco. A poorer defender would give a different answer, so the question is not whether AI helps attackers. It is which side can absorb it better.</a:t>
             </a:r>
             <a:endParaRPr lang="en-US" sz="1350" dirty="0"/>
           </a:p>
@@ -7653,7 +7885,7 @@
         </p:nvSpPr>
         <p:spPr>
           <a:xfrm>
-            <a:off x="640080" y="6327648"/>
+            <a:off x="640080" y="6355080"/>
             <a:ext cx="10881360" cy="274320"/>
           </a:xfrm>
           <a:prstGeom prst="rect">
@@ -7678,7 +7910,7 @@
                 <a:ea typeface="Calibri" pitchFamily="34" charset="-122"/>
                 <a:cs typeface="Calibri" pitchFamily="34" charset="-120"/>
               </a:rPr>
-              <a:t>Capability assessment from Butt and Ulina (2026) and Yigit et al. (2025); the wartime judgement from Willett (2022).</a:t>
+              <a:t>Butt and Ulina (2026); Yigit et al. (2025); Kabir et al. (2026); Willett (2022).</a:t>
             </a:r>
             <a:endParaRPr lang="en-US" sz="1050" dirty="0"/>
           </a:p>
@@ -7802,7 +8034,7 @@
         </p:nvSpPr>
         <p:spPr>
           <a:xfrm>
-            <a:off x="640080" y="1298448"/>
+            <a:off x="640080" y="1280160"/>
             <a:ext cx="5349240" cy="3703320"/>
           </a:xfrm>
           <a:prstGeom prst="roundRect">
@@ -7829,7 +8061,7 @@
         </p:nvSpPr>
         <p:spPr>
           <a:xfrm>
-            <a:off x="960120" y="1536192"/>
+            <a:off x="960120" y="1517904"/>
             <a:ext cx="548640" cy="548640"/>
           </a:xfrm>
           <a:prstGeom prst="ellipse">
@@ -7849,7 +8081,7 @@
         </p:nvSpPr>
         <p:spPr>
           <a:xfrm>
-            <a:off x="960120" y="1536192"/>
+            <a:off x="960120" y="1517904"/>
             <a:ext cx="548640" cy="548640"/>
           </a:xfrm>
           <a:prstGeom prst="rect">
@@ -7888,7 +8120,7 @@
         </p:nvSpPr>
         <p:spPr>
           <a:xfrm>
-            <a:off x="1664208" y="1600200"/>
+            <a:off x="1664208" y="1581912"/>
             <a:ext cx="4069080" cy="411480"/>
           </a:xfrm>
           <a:prstGeom prst="rect">
@@ -7927,7 +8159,7 @@
         </p:nvSpPr>
         <p:spPr>
           <a:xfrm>
-            <a:off x="960120" y="2286000"/>
+            <a:off x="960120" y="2267712"/>
             <a:ext cx="4709160" cy="1234440"/>
           </a:xfrm>
           <a:prstGeom prst="rect">
@@ -7955,7 +8187,7 @@
                 <a:ea typeface="Calibri" pitchFamily="34" charset="-122"/>
                 <a:cs typeface="Calibri" pitchFamily="34" charset="-120"/>
               </a:rPr>
-              <a:t>It did mean something once, because staying hidden was genuinely expensive. As AI takes over the work, it gets cheaper, and the meaning drains out of the act.</a:t>
+              <a:t>It did mean something once, because staying hidden was genuinely expensive. As AI takes over the work it gets cheaper, and the meaning drains out of the act.</a:t>
             </a:r>
             <a:endParaRPr lang="en-US" sz="1350" dirty="0"/>
           </a:p>
@@ -7969,7 +8201,7 @@
         </p:nvSpPr>
         <p:spPr>
           <a:xfrm>
-            <a:off x="960120" y="3611880"/>
+            <a:off x="960120" y="3593592"/>
             <a:ext cx="4709160" cy="1051560"/>
           </a:xfrm>
           <a:prstGeom prst="rect">
@@ -8011,7 +8243,7 @@
         </p:nvSpPr>
         <p:spPr>
           <a:xfrm>
-            <a:off x="6263640" y="1298448"/>
+            <a:off x="6263640" y="1280160"/>
             <a:ext cx="5349240" cy="3703320"/>
           </a:xfrm>
           <a:prstGeom prst="roundRect">
@@ -8038,7 +8270,7 @@
         </p:nvSpPr>
         <p:spPr>
           <a:xfrm>
-            <a:off x="6583680" y="1536192"/>
+            <a:off x="6583680" y="1517904"/>
             <a:ext cx="548640" cy="548640"/>
           </a:xfrm>
           <a:prstGeom prst="ellipse">
@@ -8058,7 +8290,7 @@
         </p:nvSpPr>
         <p:spPr>
           <a:xfrm>
-            <a:off x="6583680" y="1536192"/>
+            <a:off x="6583680" y="1517904"/>
             <a:ext cx="548640" cy="548640"/>
           </a:xfrm>
           <a:prstGeom prst="rect">
@@ -8097,7 +8329,7 @@
         </p:nvSpPr>
         <p:spPr>
           <a:xfrm>
-            <a:off x="7287768" y="1600200"/>
+            <a:off x="7287768" y="1581912"/>
             <a:ext cx="4069080" cy="411480"/>
           </a:xfrm>
           <a:prstGeom prst="rect">
@@ -8136,7 +8368,7 @@
         </p:nvSpPr>
         <p:spPr>
           <a:xfrm>
-            <a:off x="6583680" y="2286000"/>
+            <a:off x="6583680" y="2267712"/>
             <a:ext cx="4709160" cy="1234440"/>
           </a:xfrm>
           <a:prstGeom prst="rect">
@@ -8164,7 +8396,7 @@
                 <a:ea typeface="Calibri" pitchFamily="34" charset="-122"/>
                 <a:cs typeface="Calibri" pitchFamily="34" charset="-120"/>
               </a:rPr>
-              <a:t>It was never meant to say anything at all. Staying quiet, and keeping effects below the level that triggers a response, was always the whole point.</a:t>
+              <a:t>It was never meant to say anything. Staying quiet, and keeping effects below the level that triggers a response, was always the whole point.</a:t>
             </a:r>
             <a:endParaRPr lang="en-US" sz="1350" dirty="0"/>
           </a:p>
@@ -8178,7 +8410,7 @@
         </p:nvSpPr>
         <p:spPr>
           <a:xfrm>
-            <a:off x="6583680" y="3611880"/>
+            <a:off x="6583680" y="3593592"/>
             <a:ext cx="4709160" cy="1051560"/>
           </a:xfrm>
           <a:prstGeom prst="rect">
@@ -8220,7 +8452,7 @@
         </p:nvSpPr>
         <p:spPr>
           <a:xfrm>
-            <a:off x="640080" y="5138928"/>
+            <a:off x="640080" y="5166360"/>
             <a:ext cx="10881360" cy="658368"/>
           </a:xfrm>
           <a:prstGeom prst="rect">
@@ -8248,7 +8480,7 @@
                 <a:ea typeface="Cambria" pitchFamily="34" charset="-122"/>
                 <a:cs typeface="Cambria" pitchFamily="34" charset="-120"/>
               </a:rPr>
-              <a:t>The evidence so far fits B at least as well as A. That is uncomfortable, because our doctrine assumes A.</a:t>
+              <a:t>The evidence so far fits B at least as well as A. That is uncomfortable, because doctrine assumes A.</a:t>
             </a:r>
             <a:endParaRPr lang="en-US" sz="1800" dirty="0"/>
           </a:p>
@@ -8262,8 +8494,8 @@
         </p:nvSpPr>
         <p:spPr>
           <a:xfrm>
-            <a:off x="640080" y="5797296"/>
-            <a:ext cx="10881360" cy="502920"/>
+            <a:off x="640080" y="5806440"/>
+            <a:ext cx="10881360" cy="457200"/>
           </a:xfrm>
           <a:prstGeom prst="rect">
             <a:avLst/>
@@ -8287,7 +8519,7 @@
                 <a:ea typeface="Calibri" pitchFamily="34" charset="-122"/>
                 <a:cs typeface="Calibri" pitchFamily="34" charset="-120"/>
               </a:rPr>
-              <a:t>This study does not settle the question. It shows the question is answerable and that nobody has asked it.</a:t>
+              <a:t>This study does not settle it. It shows the question is answerable and that nobody has asked it.</a:t>
             </a:r>
             <a:endParaRPr lang="en-US" sz="1400" dirty="0"/>
           </a:p>

</xml_diff>